<commit_message>
Update Strauss pitch deck attachment
</commit_message>
<xml_diff>
--- a/frontend/dist/nanyang-strauss-pitch.pptx
+++ b/frontend/dist/nanyang-strauss-pitch.pptx
@@ -4,16 +4,17 @@
   <p:sldMasterIdLst>
     <p:sldMasterId id="2147483648" r:id="rId1"/>
   </p:sldMasterIdLst>
+  <p:notesMasterIdLst>
+    <p:notesMasterId r:id="rId6"/>
+  </p:notesMasterIdLst>
   <p:sldIdLst>
-    <p:sldId id="256" r:id="rId2"/>
-    <p:sldId id="257" r:id="rId3"/>
-    <p:sldId id="258" r:id="rId4"/>
+    <p:sldId id="259" r:id="rId2"/>
+    <p:sldId id="256" r:id="rId3"/>
+    <p:sldId id="257" r:id="rId4"/>
+    <p:sldId id="258" r:id="rId5"/>
   </p:sldIdLst>
-  <p:notesMasterIdLst>
-    <p:notesMasterId r:id="rId5"/>
-  </p:notesMasterIdLst>
-  <p:sldSz cx="12188952" cy="6858000"/>
-  <p:notesSz cx="6858000" cy="12188952"/>
+  <p:sldSz cx="12188825" cy="6858000"/>
+  <p:notesSz cx="6858000" cy="12188825"/>
   <p:defaultTextStyle>
     <a:lvl1pPr marL="0" algn="l" defTabSz="914400" rtl="0" eaLnBrk="1" latinLnBrk="0" hangingPunct="1">
       <a:defRPr sz="1800" kern="1200">
@@ -106,6 +107,11 @@
       </a:defRPr>
     </a:lvl9pPr>
   </p:defaultTextStyle>
+  <p:extLst>
+    <p:ext uri="{EFAFB233-063F-42B5-8137-9DF3F51BA10A}">
+      <p15:sldGuideLst xmlns:p15="http://schemas.microsoft.com/office/powerpoint/2012/main"/>
+    </p:ext>
+  </p:extLst>
 </p:presentation>
 </file>
 
@@ -131,234 +137,10 @@
           <a:chExt cx="0" cy="0"/>
         </a:xfrm>
       </p:grpSpPr>
-      <p:sp>
-        <p:nvSpPr>
-          <p:cNvPr id="2" name="Header Placeholder 1"/>
-          <p:cNvSpPr>
-            <a:spLocks noGrp="1"/>
-          </p:cNvSpPr>
-          <p:nvPr>
-            <p:ph type="hdr" sz="quarter"/>
-          </p:nvPr>
-        </p:nvSpPr>
-        <p:spPr>
-          <a:xfrm>
-            <a:off x="0" y="0"/>
-            <a:ext cx="2971800" cy="458788"/>
-          </a:xfrm>
-          <a:prstGeom prst="rect">
-            <a:avLst/>
-          </a:prstGeom>
-        </p:spPr>
-        <p:txBody>
-          <a:bodyPr vert="horz" lIns="91440" tIns="45720" rIns="91440" bIns="45720" rtlCol="0"/>
-          <a:lstStyle>
-            <a:lvl1pPr algn="l">
-              <a:defRPr sz="1200"/>
-            </a:lvl1pPr>
-          </a:lstStyle>
-          <a:p>
-            <a:endParaRPr lang="en-US"/>
-          </a:p>
-        </p:txBody>
-      </p:sp>
-      <p:sp>
-        <p:nvSpPr>
-          <p:cNvPr id="3" name="Date Placeholder 2"/>
-          <p:cNvSpPr>
-            <a:spLocks noGrp="1"/>
-          </p:cNvSpPr>
-          <p:nvPr>
-            <p:ph type="dt" idx="1"/>
-          </p:nvPr>
-        </p:nvSpPr>
-        <p:spPr>
-          <a:xfrm>
-            <a:off x="3884613" y="0"/>
-            <a:ext cx="2971800" cy="458788"/>
-          </a:xfrm>
-          <a:prstGeom prst="rect">
-            <a:avLst/>
-          </a:prstGeom>
-        </p:spPr>
-        <p:txBody>
-          <a:bodyPr vert="horz" lIns="91440" tIns="45720" rIns="91440" bIns="45720" rtlCol="0"/>
-          <a:lstStyle>
-            <a:lvl1pPr algn="r">
-              <a:defRPr sz="1200"/>
-            </a:lvl1pPr>
-          </a:lstStyle>
-          <a:p>
-            <a:fld id="{5282F153-3F37-0F45-9E97-73ACFA13230C}" type="datetimeFigureOut">
-              <a:rPr lang="en-US"/>
-              <a:t>7/23/19</a:t>
-            </a:fld>
-            <a:endParaRPr lang="en-US"/>
-          </a:p>
-        </p:txBody>
-      </p:sp>
-      <p:sp>
-        <p:nvSpPr>
-          <p:cNvPr id="4" name="Slide Image Placeholder 3"/>
-          <p:cNvSpPr>
-            <a:spLocks noGrp="1" noRot="1" noChangeAspect="1"/>
-          </p:cNvSpPr>
-          <p:nvPr>
-            <p:ph type="sldImg" idx="2"/>
-          </p:nvPr>
-        </p:nvSpPr>
-        <p:spPr>
-          <a:xfrm>
-            <a:off x="685800" y="1143000"/>
-            <a:ext cx="5486400" cy="3086100"/>
-          </a:xfrm>
-          <a:prstGeom prst="rect">
-            <a:avLst/>
-          </a:prstGeom>
-          <a:noFill/>
-          <a:ln w="12700">
-            <a:solidFill>
-              <a:prstClr val="black"/>
-            </a:solidFill>
-          </a:ln>
-        </p:spPr>
-        <p:txBody>
-          <a:bodyPr vert="horz" lIns="91440" tIns="45720" rIns="91440" bIns="45720" rtlCol="0" anchor="ctr"/>
-          <a:lstStyle/>
-          <a:p>
-            <a:endParaRPr lang="en-US"/>
-          </a:p>
-        </p:txBody>
-      </p:sp>
-      <p:sp>
-        <p:nvSpPr>
-          <p:cNvPr id="5" name="Notes Placeholder 4"/>
-          <p:cNvSpPr>
-            <a:spLocks noGrp="1"/>
-          </p:cNvSpPr>
-          <p:nvPr>
-            <p:ph type="body" sz="quarter" idx="3"/>
-          </p:nvPr>
-        </p:nvSpPr>
-        <p:spPr>
-          <a:xfrm>
-            <a:off x="685800" y="4400550"/>
-            <a:ext cx="5486400" cy="3600450"/>
-          </a:xfrm>
-          <a:prstGeom prst="rect">
-            <a:avLst/>
-          </a:prstGeom>
-        </p:spPr>
-        <p:txBody>
-          <a:bodyPr vert="horz" lIns="91440" tIns="45720" rIns="91440" bIns="45720" rtlCol="0"/>
-          <a:lstStyle/>
-          <a:p>
-            <a:pPr lvl="0"/>
-            <a:r>
-              <a:rPr lang="en-US"/>
-              <a:t>Click to edit Master text styles</a:t>
-            </a:r>
-          </a:p>
-          <a:p>
-            <a:pPr lvl="1"/>
-            <a:r>
-              <a:rPr lang="en-US"/>
-              <a:t>Second level</a:t>
-            </a:r>
-          </a:p>
-          <a:p>
-            <a:pPr lvl="2"/>
-            <a:r>
-              <a:rPr lang="en-US"/>
-              <a:t>Third level</a:t>
-            </a:r>
-          </a:p>
-          <a:p>
-            <a:pPr lvl="3"/>
-            <a:r>
-              <a:rPr lang="en-US"/>
-              <a:t>Fourth level</a:t>
-            </a:r>
-          </a:p>
-          <a:p>
-            <a:pPr lvl="4"/>
-            <a:r>
-              <a:rPr lang="en-US"/>
-              <a:t>Fifth level</a:t>
-            </a:r>
-          </a:p>
-        </p:txBody>
-      </p:sp>
-      <p:sp>
-        <p:nvSpPr>
-          <p:cNvPr id="6" name="Footer Placeholder 5"/>
-          <p:cNvSpPr>
-            <a:spLocks noGrp="1"/>
-          </p:cNvSpPr>
-          <p:nvPr>
-            <p:ph type="ftr" sz="quarter" idx="4"/>
-          </p:nvPr>
-        </p:nvSpPr>
-        <p:spPr>
-          <a:xfrm>
-            <a:off x="0" y="8685213"/>
-            <a:ext cx="2971800" cy="458787"/>
-          </a:xfrm>
-          <a:prstGeom prst="rect">
-            <a:avLst/>
-          </a:prstGeom>
-        </p:spPr>
-        <p:txBody>
-          <a:bodyPr vert="horz" lIns="91440" tIns="45720" rIns="91440" bIns="45720" rtlCol="0" anchor="b"/>
-          <a:lstStyle>
-            <a:lvl1pPr algn="l">
-              <a:defRPr sz="1200"/>
-            </a:lvl1pPr>
-          </a:lstStyle>
-          <a:p>
-            <a:endParaRPr lang="en-US"/>
-          </a:p>
-        </p:txBody>
-      </p:sp>
-      <p:sp>
-        <p:nvSpPr>
-          <p:cNvPr id="7" name="Slide Number Placeholder 6"/>
-          <p:cNvSpPr>
-            <a:spLocks noGrp="1"/>
-          </p:cNvSpPr>
-          <p:nvPr>
-            <p:ph type="sldNum" sz="quarter" idx="5"/>
-          </p:nvPr>
-        </p:nvSpPr>
-        <p:spPr>
-          <a:xfrm>
-            <a:off x="3884613" y="8685213"/>
-            <a:ext cx="2971800" cy="458787"/>
-          </a:xfrm>
-          <a:prstGeom prst="rect">
-            <a:avLst/>
-          </a:prstGeom>
-        </p:spPr>
-        <p:txBody>
-          <a:bodyPr vert="horz" lIns="91440" tIns="45720" rIns="91440" bIns="45720" rtlCol="0" anchor="b"/>
-          <a:lstStyle>
-            <a:lvl1pPr algn="r">
-              <a:defRPr sz="1200"/>
-            </a:lvl1pPr>
-          </a:lstStyle>
-          <a:p>
-            <a:fld id="{CE5E9CC1-C706-0F49-92D6-E571CC5EEA8F}" type="slidenum">
-              <a:rPr lang="en-US"/>
-              <a:t>‹#›</a:t>
-            </a:fld>
-            <a:endParaRPr lang="en-US"/>
-          </a:p>
-        </p:txBody>
-      </p:sp>
     </p:spTree>
     <p:extLst>
       <p:ext uri="{BB962C8B-B14F-4D97-AF65-F5344CB8AC3E}">
-        <p14:creationId xmlns:p14="http://schemas.microsoft.com/office/powerpoint/2010/main" val="1024086991"/>
+        <p14:creationId xmlns:p14="http://schemas.microsoft.com/office/powerpoint/2010/main" val="2594779842"/>
       </p:ext>
     </p:extLst>
   </p:cSld>
@@ -502,10 +284,6 @@
           <a:bodyPr/>
           <a:lstStyle/>
           <a:p>
-            <a:r>
-              <a:rPr lang="en-US" dirty="0"/>
-              <a:t/>
-            </a:r>
             <a:endParaRPr lang="en-US" dirty="0"/>
           </a:p>
         </p:txBody>
@@ -590,10 +368,6 @@
           <a:bodyPr/>
           <a:lstStyle/>
           <a:p>
-            <a:r>
-              <a:rPr lang="en-US" dirty="0"/>
-              <a:t/>
-            </a:r>
             <a:endParaRPr lang="en-US" dirty="0"/>
           </a:p>
         </p:txBody>
@@ -678,10 +452,6 @@
           <a:bodyPr/>
           <a:lstStyle/>
           <a:p>
-            <a:r>
-              <a:rPr lang="en-US" dirty="0"/>
-              <a:t/>
-            </a:r>
             <a:endParaRPr lang="en-US" dirty="0"/>
           </a:p>
         </p:txBody>
@@ -704,6 +474,90 @@
             <a:fld id="{F7021451-1387-4CA6-816F-3879F97B5CBC}" type="slidenum">
               <a:rPr lang="en-US"/>
               <a:t>3</a:t>
+            </a:fld>
+            <a:endParaRPr lang="en-US"/>
+          </a:p>
+        </p:txBody>
+      </p:sp>
+    </p:spTree>
+    <p:extLst>
+      <p:ext uri="{BB962C8B-B14F-4D97-AF65-F5344CB8AC3E}">
+        <p14:creationId xmlns:p14="http://schemas.microsoft.com/office/powerpoint/2010/main" val="1024086991"/>
+      </p:ext>
+    </p:extLst>
+  </p:cSld>
+  <p:clrMapOvr>
+    <a:masterClrMapping/>
+  </p:clrMapOvr>
+</p:notes>
+</file>
+
+<file path=ppt/notesSlides/notesSlide4.xml><?xml version="1.0" encoding="utf-8"?>
+<p:notes xmlns:a="http://schemas.openxmlformats.org/drawingml/2006/main" xmlns:r="http://schemas.openxmlformats.org/officeDocument/2006/relationships" xmlns:p="http://schemas.openxmlformats.org/presentationml/2006/main">
+  <p:cSld>
+    <p:spTree>
+      <p:nvGrpSpPr>
+        <p:cNvPr id="1" name=""/>
+        <p:cNvGrpSpPr/>
+        <p:nvPr/>
+      </p:nvGrpSpPr>
+      <p:grpSpPr>
+        <a:xfrm>
+          <a:off x="0" y="0"/>
+          <a:ext cx="0" cy="0"/>
+          <a:chOff x="0" y="0"/>
+          <a:chExt cx="0" cy="0"/>
+        </a:xfrm>
+      </p:grpSpPr>
+      <p:sp>
+        <p:nvSpPr>
+          <p:cNvPr id="2" name="Slide Image Placeholder 1"/>
+          <p:cNvSpPr>
+            <a:spLocks noGrp="1" noRot="1" noChangeAspect="1"/>
+          </p:cNvSpPr>
+          <p:nvPr>
+            <p:ph type="sldImg"/>
+          </p:nvPr>
+        </p:nvSpPr>
+        <p:spPr/>
+      </p:sp>
+      <p:sp>
+        <p:nvSpPr>
+          <p:cNvPr id="3" name="Notes Placeholder 2"/>
+          <p:cNvSpPr>
+            <a:spLocks noGrp="1"/>
+          </p:cNvSpPr>
+          <p:nvPr>
+            <p:ph type="body" idx="1"/>
+          </p:nvPr>
+        </p:nvSpPr>
+        <p:spPr/>
+        <p:txBody>
+          <a:bodyPr/>
+          <a:lstStyle/>
+          <a:p>
+            <a:endParaRPr lang="en-US" dirty="0"/>
+          </a:p>
+        </p:txBody>
+      </p:sp>
+      <p:sp>
+        <p:nvSpPr>
+          <p:cNvPr id="4" name="Slide Number Placeholder 3"/>
+          <p:cNvSpPr>
+            <a:spLocks noGrp="1"/>
+          </p:cNvSpPr>
+          <p:nvPr>
+            <p:ph type="sldNum" sz="quarter" idx="10"/>
+          </p:nvPr>
+        </p:nvSpPr>
+        <p:spPr/>
+        <p:txBody>
+          <a:bodyPr/>
+          <a:lstStyle/>
+          <a:p>
+            <a:fld id="{F7021451-1387-4CA6-816F-3879F97B5CBC}" type="slidenum">
+              <a:rPr lang="en-US"/>
+              <a:t>4</a:t>
             </a:fld>
             <a:endParaRPr lang="en-US"/>
           </a:p>
@@ -755,6 +609,11 @@
 <file path=ppt/slideMasters/slideMaster1.xml><?xml version="1.0" encoding="utf-8"?>
 <p:sldMaster xmlns:a="http://schemas.openxmlformats.org/drawingml/2006/main" xmlns:r="http://schemas.openxmlformats.org/officeDocument/2006/relationships" xmlns:p="http://schemas.openxmlformats.org/presentationml/2006/main">
   <p:cSld>
+    <p:bg>
+      <p:bgRef idx="1001">
+        <a:schemeClr val="bg1"/>
+      </p:bgRef>
+    </p:bg>
     <p:spTree>
       <p:nvGrpSpPr>
         <p:cNvPr id="1" name=""/>
@@ -1031,12 +890,2840 @@
 
 <file path=ppt/slides/slide1.xml><?xml version="1.0" encoding="utf-8"?>
 <p:sld xmlns:a="http://schemas.openxmlformats.org/drawingml/2006/main" xmlns:r="http://schemas.openxmlformats.org/officeDocument/2006/relationships" xmlns:p="http://schemas.openxmlformats.org/presentationml/2006/main">
+  <p:cSld>
+    <p:spTree>
+      <p:nvGrpSpPr>
+        <p:cNvPr id="1" name=""/>
+        <p:cNvGrpSpPr/>
+        <p:nvPr/>
+      </p:nvGrpSpPr>
+      <p:grpSpPr>
+        <a:xfrm>
+          <a:off x="0" y="0"/>
+          <a:ext cx="0" cy="0"/>
+          <a:chOff x="0" y="0"/>
+          <a:chExt cx="0" cy="0"/>
+        </a:xfrm>
+      </p:grpSpPr>
+      <p:sp>
+        <p:nvSpPr>
+          <p:cNvPr id="2" name="Shape 0"/>
+          <p:cNvSpPr/>
+          <p:nvPr/>
+        </p:nvSpPr>
+        <p:spPr>
+          <a:xfrm>
+            <a:off x="0" y="0"/>
+            <a:ext cx="12188952" cy="1170432"/>
+          </a:xfrm>
+          <a:prstGeom prst="rect">
+            <a:avLst/>
+          </a:prstGeom>
+          <a:solidFill>
+            <a:srgbClr val="2B3640"/>
+          </a:solidFill>
+          <a:ln/>
+        </p:spPr>
+      </p:sp>
+      <p:sp>
+        <p:nvSpPr>
+          <p:cNvPr id="3" name="Text 1"/>
+          <p:cNvSpPr/>
+          <p:nvPr/>
+        </p:nvSpPr>
+        <p:spPr>
+          <a:xfrm>
+            <a:off x="457200" y="164592"/>
+            <a:ext cx="3657600" cy="237744"/>
+          </a:xfrm>
+          <a:prstGeom prst="rect">
+            <a:avLst/>
+          </a:prstGeom>
+          <a:noFill/>
+          <a:ln/>
+        </p:spPr>
+        <p:txBody>
+          <a:bodyPr wrap="square" lIns="0" tIns="0" rIns="0" bIns="0" rtlCol="0" anchor="ctr"/>
+          <a:lstStyle/>
+          <a:p>
+            <a:pPr marL="0" indent="0">
+              <a:buNone/>
+            </a:pPr>
+            <a:r>
+              <a:rPr lang="en-US" sz="1000" b="1" kern="0" spc="200" dirty="0">
+                <a:solidFill>
+                  <a:srgbClr val="DD841C"/>
+                </a:solidFill>
+                <a:latin typeface="Arial" pitchFamily="34" charset="0"/>
+                <a:ea typeface="Arial" pitchFamily="34" charset="-122"/>
+                <a:cs typeface="Arial" pitchFamily="34" charset="-120"/>
+              </a:rPr>
+              <a:t>PAGE 1 / 2</a:t>
+            </a:r>
+            <a:endParaRPr lang="en-US" sz="1000" dirty="0"/>
+          </a:p>
+        </p:txBody>
+      </p:sp>
+      <p:sp>
+        <p:nvSpPr>
+          <p:cNvPr id="4" name="Text 2"/>
+          <p:cNvSpPr/>
+          <p:nvPr/>
+        </p:nvSpPr>
+        <p:spPr>
+          <a:xfrm>
+            <a:off x="457200" y="402336"/>
+            <a:ext cx="10515600" cy="457200"/>
+          </a:xfrm>
+          <a:prstGeom prst="rect">
+            <a:avLst/>
+          </a:prstGeom>
+          <a:noFill/>
+          <a:ln/>
+        </p:spPr>
+        <p:txBody>
+          <a:bodyPr wrap="square" lIns="0" tIns="0" rIns="0" bIns="0" rtlCol="0" anchor="ctr"/>
+          <a:lstStyle/>
+          <a:p>
+            <a:pPr marL="0" indent="0">
+              <a:buNone/>
+            </a:pPr>
+            <a:r>
+              <a:rPr lang="en-US" sz="2700" b="1" dirty="0">
+                <a:solidFill>
+                  <a:srgbClr val="FFFFFF"/>
+                </a:solidFill>
+                <a:latin typeface="Arial" pitchFamily="34" charset="0"/>
+                <a:ea typeface="Arial" pitchFamily="34" charset="-122"/>
+                <a:cs typeface="Arial" pitchFamily="34" charset="-120"/>
+              </a:rPr>
+              <a:t>STRAUSS — TOP 5 COLLECTIONS</a:t>
+            </a:r>
+            <a:endParaRPr lang="en-US" sz="2700" dirty="0"/>
+          </a:p>
+        </p:txBody>
+      </p:sp>
+      <p:sp>
+        <p:nvSpPr>
+          <p:cNvPr id="5" name="Text 3"/>
+          <p:cNvSpPr/>
+          <p:nvPr/>
+        </p:nvSpPr>
+        <p:spPr>
+          <a:xfrm>
+            <a:off x="457200" y="886968"/>
+            <a:ext cx="11247120" cy="256032"/>
+          </a:xfrm>
+          <a:prstGeom prst="rect">
+            <a:avLst/>
+          </a:prstGeom>
+          <a:noFill/>
+          <a:ln/>
+        </p:spPr>
+        <p:txBody>
+          <a:bodyPr wrap="square" lIns="0" tIns="0" rIns="0" bIns="0" rtlCol="0" anchor="ctr"/>
+          <a:lstStyle/>
+          <a:p>
+            <a:pPr marL="0" indent="0">
+              <a:buNone/>
+            </a:pPr>
+            <a:r>
+              <a:rPr lang="en-US" sz="1150" i="1" dirty="0">
+                <a:solidFill>
+                  <a:srgbClr val="C9D2D8"/>
+                </a:solidFill>
+                <a:latin typeface="Calibri" pitchFamily="34" charset="0"/>
+                <a:ea typeface="Calibri" pitchFamily="34" charset="-122"/>
+                <a:cs typeface="Calibri" pitchFamily="34" charset="-120"/>
+              </a:rPr>
+              <a:t>Men &amp; Women · inferred from website signals (badges, hero placement, default best-selling sort) — not internal sales data</a:t>
+            </a:r>
+            <a:endParaRPr lang="en-US" sz="1150" dirty="0"/>
+          </a:p>
+        </p:txBody>
+      </p:sp>
+      <p:sp>
+        <p:nvSpPr>
+          <p:cNvPr id="6" name="Shape 4"/>
+          <p:cNvSpPr/>
+          <p:nvPr/>
+        </p:nvSpPr>
+        <p:spPr>
+          <a:xfrm>
+            <a:off x="457200" y="1389888"/>
+            <a:ext cx="457200" cy="457200"/>
+          </a:xfrm>
+          <a:prstGeom prst="ellipse">
+            <a:avLst/>
+          </a:prstGeom>
+          <a:solidFill>
+            <a:srgbClr val="DD841C"/>
+          </a:solidFill>
+          <a:ln/>
+        </p:spPr>
+      </p:sp>
+      <p:pic>
+        <p:nvPicPr>
+          <p:cNvPr id="7" name="Image 0" descr="preencoded.png"/>
+          <p:cNvPicPr>
+            <a:picLocks noChangeAspect="1"/>
+          </p:cNvPicPr>
+          <p:nvPr/>
+        </p:nvPicPr>
+        <p:blipFill>
+          <a:blip r:embed="rId3"/>
+          <a:stretch>
+            <a:fillRect/>
+          </a:stretch>
+        </p:blipFill>
+        <p:spPr>
+          <a:xfrm>
+            <a:off x="612648" y="1481328"/>
+            <a:ext cx="164592" cy="274320"/>
+          </a:xfrm>
+          <a:prstGeom prst="rect">
+            <a:avLst/>
+          </a:prstGeom>
+        </p:spPr>
+      </p:pic>
+      <p:sp>
+        <p:nvSpPr>
+          <p:cNvPr id="8" name="Text 5"/>
+          <p:cNvSpPr/>
+          <p:nvPr/>
+        </p:nvSpPr>
+        <p:spPr>
+          <a:xfrm>
+            <a:off x="1024128" y="1389888"/>
+            <a:ext cx="4919472" cy="457200"/>
+          </a:xfrm>
+          <a:prstGeom prst="rect">
+            <a:avLst/>
+          </a:prstGeom>
+          <a:noFill/>
+          <a:ln/>
+        </p:spPr>
+        <p:txBody>
+          <a:bodyPr wrap="square" lIns="0" tIns="0" rIns="0" bIns="0" rtlCol="0" anchor="ctr"/>
+          <a:lstStyle/>
+          <a:p>
+            <a:pPr marL="0" indent="0">
+              <a:buNone/>
+            </a:pPr>
+            <a:r>
+              <a:rPr lang="en-US" sz="1800" b="1" dirty="0">
+                <a:solidFill>
+                  <a:srgbClr val="2B3640"/>
+                </a:solidFill>
+                <a:latin typeface="Arial" pitchFamily="34" charset="0"/>
+                <a:ea typeface="Arial" pitchFamily="34" charset="-122"/>
+                <a:cs typeface="Arial" pitchFamily="34" charset="-120"/>
+              </a:rPr>
+              <a:t>MEN</a:t>
+            </a:r>
+            <a:endParaRPr lang="en-US" sz="1800" dirty="0"/>
+          </a:p>
+        </p:txBody>
+      </p:sp>
+      <p:sp>
+        <p:nvSpPr>
+          <p:cNvPr id="9" name="Shape 6"/>
+          <p:cNvSpPr/>
+          <p:nvPr/>
+        </p:nvSpPr>
+        <p:spPr>
+          <a:xfrm>
+            <a:off x="457200" y="1993392"/>
+            <a:ext cx="5486400" cy="758952"/>
+          </a:xfrm>
+          <a:prstGeom prst="roundRect">
+            <a:avLst>
+              <a:gd name="adj" fmla="val 7229"/>
+            </a:avLst>
+          </a:prstGeom>
+          <a:solidFill>
+            <a:srgbClr val="F3F5F6"/>
+          </a:solidFill>
+          <a:ln/>
+          <a:effectLst>
+            <a:outerShdw blurRad="88900" dist="25400" dir="5400000" algn="bl" rotWithShape="0">
+              <a:srgbClr val="000000">
+                <a:alpha val="13000"/>
+              </a:srgbClr>
+            </a:outerShdw>
+          </a:effectLst>
+        </p:spPr>
+      </p:sp>
+      <p:sp>
+        <p:nvSpPr>
+          <p:cNvPr id="10" name="Shape 7"/>
+          <p:cNvSpPr/>
+          <p:nvPr/>
+        </p:nvSpPr>
+        <p:spPr>
+          <a:xfrm>
+            <a:off x="621792" y="2148840"/>
+            <a:ext cx="457200" cy="457200"/>
+          </a:xfrm>
+          <a:prstGeom prst="ellipse">
+            <a:avLst/>
+          </a:prstGeom>
+          <a:solidFill>
+            <a:srgbClr val="2B3640"/>
+          </a:solidFill>
+          <a:ln/>
+        </p:spPr>
+      </p:sp>
+      <p:sp>
+        <p:nvSpPr>
+          <p:cNvPr id="11" name="Text 8"/>
+          <p:cNvSpPr/>
+          <p:nvPr/>
+        </p:nvSpPr>
+        <p:spPr>
+          <a:xfrm>
+            <a:off x="621792" y="2148840"/>
+            <a:ext cx="457200" cy="457200"/>
+          </a:xfrm>
+          <a:prstGeom prst="rect">
+            <a:avLst/>
+          </a:prstGeom>
+          <a:noFill/>
+          <a:ln/>
+        </p:spPr>
+        <p:txBody>
+          <a:bodyPr wrap="square" lIns="0" tIns="0" rIns="0" bIns="0" rtlCol="0" anchor="ctr"/>
+          <a:lstStyle/>
+          <a:p>
+            <a:pPr marL="0" indent="0" algn="ctr">
+              <a:buNone/>
+            </a:pPr>
+            <a:r>
+              <a:rPr lang="en-US" sz="1800" b="1" dirty="0">
+                <a:solidFill>
+                  <a:srgbClr val="DD841C"/>
+                </a:solidFill>
+                <a:latin typeface="Arial" pitchFamily="34" charset="0"/>
+                <a:ea typeface="Arial" pitchFamily="34" charset="-122"/>
+                <a:cs typeface="Arial" pitchFamily="34" charset="-120"/>
+              </a:rPr>
+              <a:t>1</a:t>
+            </a:r>
+            <a:endParaRPr lang="en-US" sz="1800" dirty="0"/>
+          </a:p>
+        </p:txBody>
+      </p:sp>
+      <p:sp>
+        <p:nvSpPr>
+          <p:cNvPr id="12" name="Text 9"/>
+          <p:cNvSpPr/>
+          <p:nvPr/>
+        </p:nvSpPr>
+        <p:spPr>
+          <a:xfrm>
+            <a:off x="1243584" y="2075688"/>
+            <a:ext cx="3328416" cy="256032"/>
+          </a:xfrm>
+          <a:prstGeom prst="rect">
+            <a:avLst/>
+          </a:prstGeom>
+          <a:noFill/>
+          <a:ln/>
+        </p:spPr>
+        <p:txBody>
+          <a:bodyPr wrap="square" lIns="0" tIns="0" rIns="0" bIns="0" rtlCol="0" anchor="ctr"/>
+          <a:lstStyle/>
+          <a:p>
+            <a:pPr marL="0" indent="0">
+              <a:buNone/>
+            </a:pPr>
+            <a:r>
+              <a:rPr lang="en-US" sz="1400" b="1" dirty="0">
+                <a:solidFill>
+                  <a:srgbClr val="20292F"/>
+                </a:solidFill>
+                <a:latin typeface="Arial" pitchFamily="34" charset="0"/>
+                <a:ea typeface="Arial" pitchFamily="34" charset="-122"/>
+                <a:cs typeface="Arial" pitchFamily="34" charset="-120"/>
+              </a:rPr>
+              <a:t>e.s.motion 2020</a:t>
+            </a:r>
+            <a:endParaRPr lang="en-US" sz="1400" dirty="0"/>
+          </a:p>
+        </p:txBody>
+      </p:sp>
+      <p:sp>
+        <p:nvSpPr>
+          <p:cNvPr id="13" name="Text 10"/>
+          <p:cNvSpPr/>
+          <p:nvPr/>
+        </p:nvSpPr>
+        <p:spPr>
+          <a:xfrm>
+            <a:off x="4572000" y="2075688"/>
+            <a:ext cx="1188720" cy="256032"/>
+          </a:xfrm>
+          <a:prstGeom prst="rect">
+            <a:avLst/>
+          </a:prstGeom>
+          <a:noFill/>
+          <a:ln/>
+        </p:spPr>
+        <p:txBody>
+          <a:bodyPr wrap="square" lIns="0" tIns="0" rIns="0" bIns="0" rtlCol="0" anchor="ctr"/>
+          <a:lstStyle/>
+          <a:p>
+            <a:pPr marL="0" indent="0" algn="r">
+              <a:buNone/>
+            </a:pPr>
+            <a:r>
+              <a:rPr lang="en-US" sz="1300" b="1" dirty="0">
+                <a:solidFill>
+                  <a:srgbClr val="DD841C"/>
+                </a:solidFill>
+                <a:latin typeface="Arial" pitchFamily="34" charset="0"/>
+                <a:ea typeface="Arial" pitchFamily="34" charset="-122"/>
+                <a:cs typeface="Arial" pitchFamily="34" charset="-120"/>
+              </a:rPr>
+              <a:t>$120</a:t>
+            </a:r>
+            <a:endParaRPr lang="en-US" sz="1300" dirty="0"/>
+          </a:p>
+        </p:txBody>
+      </p:sp>
+      <p:sp>
+        <p:nvSpPr>
+          <p:cNvPr id="14" name="Text 11"/>
+          <p:cNvSpPr/>
+          <p:nvPr/>
+        </p:nvSpPr>
+        <p:spPr>
+          <a:xfrm>
+            <a:off x="1243584" y="2331720"/>
+            <a:ext cx="4517136" cy="201168"/>
+          </a:xfrm>
+          <a:prstGeom prst="rect">
+            <a:avLst/>
+          </a:prstGeom>
+          <a:noFill/>
+          <a:ln/>
+        </p:spPr>
+        <p:txBody>
+          <a:bodyPr wrap="square" lIns="0" tIns="0" rIns="0" bIns="0" rtlCol="0" anchor="ctr"/>
+          <a:lstStyle/>
+          <a:p>
+            <a:pPr marL="0" indent="0">
+              <a:buNone/>
+            </a:pPr>
+            <a:r>
+              <a:rPr lang="en-US" sz="1050" dirty="0">
+                <a:solidFill>
+                  <a:srgbClr val="5C6B76"/>
+                </a:solidFill>
+                <a:latin typeface="Calibri" pitchFamily="34" charset="0"/>
+                <a:ea typeface="Calibri" pitchFamily="34" charset="-122"/>
+                <a:cs typeface="Calibri" pitchFamily="34" charset="-120"/>
+              </a:rPr>
+              <a:t>Flagship cargo work pant</a:t>
+            </a:r>
+            <a:endParaRPr lang="en-US" sz="1050" dirty="0"/>
+          </a:p>
+        </p:txBody>
+      </p:sp>
+      <p:sp>
+        <p:nvSpPr>
+          <p:cNvPr id="15" name="Text 12"/>
+          <p:cNvSpPr/>
+          <p:nvPr/>
+        </p:nvSpPr>
+        <p:spPr>
+          <a:xfrm>
+            <a:off x="1243584" y="2523744"/>
+            <a:ext cx="4517136" cy="182880"/>
+          </a:xfrm>
+          <a:prstGeom prst="rect">
+            <a:avLst/>
+          </a:prstGeom>
+          <a:noFill/>
+          <a:ln/>
+        </p:spPr>
+        <p:txBody>
+          <a:bodyPr wrap="square" lIns="0" tIns="0" rIns="0" bIns="0" rtlCol="0" anchor="ctr"/>
+          <a:lstStyle/>
+          <a:p>
+            <a:pPr marL="0" indent="0">
+              <a:buNone/>
+            </a:pPr>
+            <a:r>
+              <a:rPr lang="en-US" sz="850" b="1" kern="0" spc="50" dirty="0">
+                <a:solidFill>
+                  <a:srgbClr val="9A6212"/>
+                </a:solidFill>
+                <a:latin typeface="Arial" pitchFamily="34" charset="0"/>
+                <a:ea typeface="Arial" pitchFamily="34" charset="-122"/>
+                <a:cs typeface="Arial" pitchFamily="34" charset="-120"/>
+              </a:rPr>
+              <a:t>TOP SELLER · “7+ Million Worn”</a:t>
+            </a:r>
+            <a:endParaRPr lang="en-US" sz="850" dirty="0"/>
+          </a:p>
+        </p:txBody>
+      </p:sp>
+      <p:sp>
+        <p:nvSpPr>
+          <p:cNvPr id="16" name="Shape 13"/>
+          <p:cNvSpPr/>
+          <p:nvPr/>
+        </p:nvSpPr>
+        <p:spPr>
+          <a:xfrm>
+            <a:off x="457200" y="2843784"/>
+            <a:ext cx="5486400" cy="758952"/>
+          </a:xfrm>
+          <a:prstGeom prst="roundRect">
+            <a:avLst>
+              <a:gd name="adj" fmla="val 7229"/>
+            </a:avLst>
+          </a:prstGeom>
+          <a:solidFill>
+            <a:srgbClr val="F3F5F6"/>
+          </a:solidFill>
+          <a:ln/>
+          <a:effectLst>
+            <a:outerShdw blurRad="88900" dist="25400" dir="5400000" algn="bl" rotWithShape="0">
+              <a:srgbClr val="000000">
+                <a:alpha val="13000"/>
+              </a:srgbClr>
+            </a:outerShdw>
+          </a:effectLst>
+        </p:spPr>
+      </p:sp>
+      <p:sp>
+        <p:nvSpPr>
+          <p:cNvPr id="17" name="Shape 14"/>
+          <p:cNvSpPr/>
+          <p:nvPr/>
+        </p:nvSpPr>
+        <p:spPr>
+          <a:xfrm>
+            <a:off x="621792" y="2999232"/>
+            <a:ext cx="457200" cy="457200"/>
+          </a:xfrm>
+          <a:prstGeom prst="ellipse">
+            <a:avLst/>
+          </a:prstGeom>
+          <a:solidFill>
+            <a:srgbClr val="2B3640"/>
+          </a:solidFill>
+          <a:ln/>
+        </p:spPr>
+      </p:sp>
+      <p:sp>
+        <p:nvSpPr>
+          <p:cNvPr id="18" name="Text 15"/>
+          <p:cNvSpPr/>
+          <p:nvPr/>
+        </p:nvSpPr>
+        <p:spPr>
+          <a:xfrm>
+            <a:off x="621792" y="2999232"/>
+            <a:ext cx="457200" cy="457200"/>
+          </a:xfrm>
+          <a:prstGeom prst="rect">
+            <a:avLst/>
+          </a:prstGeom>
+          <a:noFill/>
+          <a:ln/>
+        </p:spPr>
+        <p:txBody>
+          <a:bodyPr wrap="square" lIns="0" tIns="0" rIns="0" bIns="0" rtlCol="0" anchor="ctr"/>
+          <a:lstStyle/>
+          <a:p>
+            <a:pPr marL="0" indent="0" algn="ctr">
+              <a:buNone/>
+            </a:pPr>
+            <a:r>
+              <a:rPr lang="en-US" sz="1800" b="1" dirty="0">
+                <a:solidFill>
+                  <a:srgbClr val="DD841C"/>
+                </a:solidFill>
+                <a:latin typeface="Arial" pitchFamily="34" charset="0"/>
+                <a:ea typeface="Arial" pitchFamily="34" charset="-122"/>
+                <a:cs typeface="Arial" pitchFamily="34" charset="-120"/>
+              </a:rPr>
+              <a:t>2</a:t>
+            </a:r>
+            <a:endParaRPr lang="en-US" sz="1800" dirty="0"/>
+          </a:p>
+        </p:txBody>
+      </p:sp>
+      <p:sp>
+        <p:nvSpPr>
+          <p:cNvPr id="19" name="Text 16"/>
+          <p:cNvSpPr/>
+          <p:nvPr/>
+        </p:nvSpPr>
+        <p:spPr>
+          <a:xfrm>
+            <a:off x="1243584" y="2926080"/>
+            <a:ext cx="3328416" cy="256032"/>
+          </a:xfrm>
+          <a:prstGeom prst="rect">
+            <a:avLst/>
+          </a:prstGeom>
+          <a:noFill/>
+          <a:ln/>
+        </p:spPr>
+        <p:txBody>
+          <a:bodyPr wrap="square" lIns="0" tIns="0" rIns="0" bIns="0" rtlCol="0" anchor="ctr"/>
+          <a:lstStyle/>
+          <a:p>
+            <a:pPr marL="0" indent="0">
+              <a:buNone/>
+            </a:pPr>
+            <a:r>
+              <a:rPr lang="en-US" sz="1400" b="1" dirty="0">
+                <a:solidFill>
+                  <a:srgbClr val="20292F"/>
+                </a:solidFill>
+                <a:latin typeface="Arial" pitchFamily="34" charset="0"/>
+                <a:ea typeface="Arial" pitchFamily="34" charset="-122"/>
+                <a:cs typeface="Arial" pitchFamily="34" charset="-120"/>
+              </a:rPr>
+              <a:t>e.s.motion ten</a:t>
+            </a:r>
+            <a:endParaRPr lang="en-US" sz="1400" dirty="0"/>
+          </a:p>
+        </p:txBody>
+      </p:sp>
+      <p:sp>
+        <p:nvSpPr>
+          <p:cNvPr id="20" name="Text 17"/>
+          <p:cNvSpPr/>
+          <p:nvPr/>
+        </p:nvSpPr>
+        <p:spPr>
+          <a:xfrm>
+            <a:off x="4572000" y="2926080"/>
+            <a:ext cx="1188720" cy="256032"/>
+          </a:xfrm>
+          <a:prstGeom prst="rect">
+            <a:avLst/>
+          </a:prstGeom>
+          <a:noFill/>
+          <a:ln/>
+        </p:spPr>
+        <p:txBody>
+          <a:bodyPr wrap="square" lIns="0" tIns="0" rIns="0" bIns="0" rtlCol="0" anchor="ctr"/>
+          <a:lstStyle/>
+          <a:p>
+            <a:pPr marL="0" indent="0" algn="r">
+              <a:buNone/>
+            </a:pPr>
+            <a:r>
+              <a:rPr lang="en-US" sz="1300" b="1" dirty="0">
+                <a:solidFill>
+                  <a:srgbClr val="DD841C"/>
+                </a:solidFill>
+                <a:latin typeface="Arial" pitchFamily="34" charset="0"/>
+                <a:ea typeface="Arial" pitchFamily="34" charset="-122"/>
+                <a:cs typeface="Arial" pitchFamily="34" charset="-120"/>
+              </a:rPr>
+              <a:t>$120</a:t>
+            </a:r>
+            <a:endParaRPr lang="en-US" sz="1300" dirty="0"/>
+          </a:p>
+        </p:txBody>
+      </p:sp>
+      <p:sp>
+        <p:nvSpPr>
+          <p:cNvPr id="21" name="Text 18"/>
+          <p:cNvSpPr/>
+          <p:nvPr/>
+        </p:nvSpPr>
+        <p:spPr>
+          <a:xfrm>
+            <a:off x="1243584" y="3182112"/>
+            <a:ext cx="4517136" cy="201168"/>
+          </a:xfrm>
+          <a:prstGeom prst="rect">
+            <a:avLst/>
+          </a:prstGeom>
+          <a:noFill/>
+          <a:ln/>
+        </p:spPr>
+        <p:txBody>
+          <a:bodyPr wrap="square" lIns="0" tIns="0" rIns="0" bIns="0" rtlCol="0" anchor="ctr"/>
+          <a:lstStyle/>
+          <a:p>
+            <a:pPr marL="0" indent="0">
+              <a:buNone/>
+            </a:pPr>
+            <a:r>
+              <a:rPr lang="en-US" sz="1050" dirty="0">
+                <a:solidFill>
+                  <a:srgbClr val="5C6B76"/>
+                </a:solidFill>
+                <a:latin typeface="Calibri" pitchFamily="34" charset="0"/>
+                <a:ea typeface="Calibri" pitchFamily="34" charset="-122"/>
+                <a:cs typeface="Calibri" pitchFamily="34" charset="-120"/>
+              </a:rPr>
+              <a:t>Technical tailored work pants</a:t>
+            </a:r>
+            <a:endParaRPr lang="en-US" sz="1050" dirty="0"/>
+          </a:p>
+        </p:txBody>
+      </p:sp>
+      <p:sp>
+        <p:nvSpPr>
+          <p:cNvPr id="22" name="Text 19"/>
+          <p:cNvSpPr/>
+          <p:nvPr/>
+        </p:nvSpPr>
+        <p:spPr>
+          <a:xfrm>
+            <a:off x="1243584" y="3374136"/>
+            <a:ext cx="4517136" cy="182880"/>
+          </a:xfrm>
+          <a:prstGeom prst="rect">
+            <a:avLst/>
+          </a:prstGeom>
+          <a:noFill/>
+          <a:ln/>
+        </p:spPr>
+        <p:txBody>
+          <a:bodyPr wrap="square" lIns="0" tIns="0" rIns="0" bIns="0" rtlCol="0" anchor="ctr"/>
+          <a:lstStyle/>
+          <a:p>
+            <a:pPr marL="0" indent="0">
+              <a:buNone/>
+            </a:pPr>
+            <a:r>
+              <a:rPr lang="en-US" sz="850" b="1" kern="0" spc="50" dirty="0">
+                <a:solidFill>
+                  <a:srgbClr val="9A6212"/>
+                </a:solidFill>
+                <a:latin typeface="Arial" pitchFamily="34" charset="0"/>
+                <a:ea typeface="Arial" pitchFamily="34" charset="-122"/>
+                <a:cs typeface="Arial" pitchFamily="34" charset="-120"/>
+              </a:rPr>
+              <a:t>HERO BANNER · 5 colors</a:t>
+            </a:r>
+            <a:endParaRPr lang="en-US" sz="850" dirty="0"/>
+          </a:p>
+        </p:txBody>
+      </p:sp>
+      <p:sp>
+        <p:nvSpPr>
+          <p:cNvPr id="23" name="Shape 20"/>
+          <p:cNvSpPr/>
+          <p:nvPr/>
+        </p:nvSpPr>
+        <p:spPr>
+          <a:xfrm>
+            <a:off x="457200" y="3694176"/>
+            <a:ext cx="5486400" cy="758952"/>
+          </a:xfrm>
+          <a:prstGeom prst="roundRect">
+            <a:avLst>
+              <a:gd name="adj" fmla="val 7229"/>
+            </a:avLst>
+          </a:prstGeom>
+          <a:solidFill>
+            <a:srgbClr val="F3F5F6"/>
+          </a:solidFill>
+          <a:ln/>
+          <a:effectLst>
+            <a:outerShdw blurRad="88900" dist="25400" dir="5400000" algn="bl" rotWithShape="0">
+              <a:srgbClr val="000000">
+                <a:alpha val="13000"/>
+              </a:srgbClr>
+            </a:outerShdw>
+          </a:effectLst>
+        </p:spPr>
+      </p:sp>
+      <p:sp>
+        <p:nvSpPr>
+          <p:cNvPr id="24" name="Shape 21"/>
+          <p:cNvSpPr/>
+          <p:nvPr/>
+        </p:nvSpPr>
+        <p:spPr>
+          <a:xfrm>
+            <a:off x="621792" y="3849624"/>
+            <a:ext cx="457200" cy="457200"/>
+          </a:xfrm>
+          <a:prstGeom prst="ellipse">
+            <a:avLst/>
+          </a:prstGeom>
+          <a:solidFill>
+            <a:srgbClr val="2B3640"/>
+          </a:solidFill>
+          <a:ln/>
+        </p:spPr>
+      </p:sp>
+      <p:sp>
+        <p:nvSpPr>
+          <p:cNvPr id="25" name="Text 22"/>
+          <p:cNvSpPr/>
+          <p:nvPr/>
+        </p:nvSpPr>
+        <p:spPr>
+          <a:xfrm>
+            <a:off x="621792" y="3849624"/>
+            <a:ext cx="457200" cy="457200"/>
+          </a:xfrm>
+          <a:prstGeom prst="rect">
+            <a:avLst/>
+          </a:prstGeom>
+          <a:noFill/>
+          <a:ln/>
+        </p:spPr>
+        <p:txBody>
+          <a:bodyPr wrap="square" lIns="0" tIns="0" rIns="0" bIns="0" rtlCol="0" anchor="ctr"/>
+          <a:lstStyle/>
+          <a:p>
+            <a:pPr marL="0" indent="0" algn="ctr">
+              <a:buNone/>
+            </a:pPr>
+            <a:r>
+              <a:rPr lang="en-US" sz="1800" b="1" dirty="0">
+                <a:solidFill>
+                  <a:srgbClr val="DD841C"/>
+                </a:solidFill>
+                <a:latin typeface="Arial" pitchFamily="34" charset="0"/>
+                <a:ea typeface="Arial" pitchFamily="34" charset="-122"/>
+                <a:cs typeface="Arial" pitchFamily="34" charset="-120"/>
+              </a:rPr>
+              <a:t>3</a:t>
+            </a:r>
+            <a:endParaRPr lang="en-US" sz="1800" dirty="0"/>
+          </a:p>
+        </p:txBody>
+      </p:sp>
+      <p:sp>
+        <p:nvSpPr>
+          <p:cNvPr id="26" name="Text 23"/>
+          <p:cNvSpPr/>
+          <p:nvPr/>
+        </p:nvSpPr>
+        <p:spPr>
+          <a:xfrm>
+            <a:off x="1243584" y="3776472"/>
+            <a:ext cx="3328416" cy="256032"/>
+          </a:xfrm>
+          <a:prstGeom prst="rect">
+            <a:avLst/>
+          </a:prstGeom>
+          <a:noFill/>
+          <a:ln/>
+        </p:spPr>
+        <p:txBody>
+          <a:bodyPr wrap="square" lIns="0" tIns="0" rIns="0" bIns="0" rtlCol="0" anchor="ctr"/>
+          <a:lstStyle/>
+          <a:p>
+            <a:pPr marL="0" indent="0">
+              <a:buNone/>
+            </a:pPr>
+            <a:r>
+              <a:rPr lang="en-US" sz="1400" b="1" dirty="0">
+                <a:solidFill>
+                  <a:srgbClr val="20292F"/>
+                </a:solidFill>
+                <a:latin typeface="Arial" pitchFamily="34" charset="0"/>
+                <a:ea typeface="Arial" pitchFamily="34" charset="-122"/>
+                <a:cs typeface="Arial" pitchFamily="34" charset="-120"/>
+              </a:rPr>
+              <a:t>e.s.t:aktik</a:t>
+            </a:r>
+            <a:endParaRPr lang="en-US" sz="1400" dirty="0"/>
+          </a:p>
+        </p:txBody>
+      </p:sp>
+      <p:sp>
+        <p:nvSpPr>
+          <p:cNvPr id="27" name="Text 24"/>
+          <p:cNvSpPr/>
+          <p:nvPr/>
+        </p:nvSpPr>
+        <p:spPr>
+          <a:xfrm>
+            <a:off x="4572000" y="3776472"/>
+            <a:ext cx="1188720" cy="256032"/>
+          </a:xfrm>
+          <a:prstGeom prst="rect">
+            <a:avLst/>
+          </a:prstGeom>
+          <a:noFill/>
+          <a:ln/>
+        </p:spPr>
+        <p:txBody>
+          <a:bodyPr wrap="square" lIns="0" tIns="0" rIns="0" bIns="0" rtlCol="0" anchor="ctr"/>
+          <a:lstStyle/>
+          <a:p>
+            <a:pPr marL="0" indent="0" algn="r">
+              <a:buNone/>
+            </a:pPr>
+            <a:r>
+              <a:rPr lang="en-US" sz="1300" b="1" dirty="0">
+                <a:solidFill>
+                  <a:srgbClr val="DD841C"/>
+                </a:solidFill>
+                <a:latin typeface="Arial" pitchFamily="34" charset="0"/>
+                <a:ea typeface="Arial" pitchFamily="34" charset="-122"/>
+                <a:cs typeface="Arial" pitchFamily="34" charset="-120"/>
+              </a:rPr>
+              <a:t>$40–130</a:t>
+            </a:r>
+            <a:endParaRPr lang="en-US" sz="1300" dirty="0"/>
+          </a:p>
+        </p:txBody>
+      </p:sp>
+      <p:sp>
+        <p:nvSpPr>
+          <p:cNvPr id="28" name="Text 25"/>
+          <p:cNvSpPr/>
+          <p:nvPr/>
+        </p:nvSpPr>
+        <p:spPr>
+          <a:xfrm>
+            <a:off x="1243584" y="4032504"/>
+            <a:ext cx="4517136" cy="201168"/>
+          </a:xfrm>
+          <a:prstGeom prst="rect">
+            <a:avLst/>
+          </a:prstGeom>
+          <a:noFill/>
+          <a:ln/>
+        </p:spPr>
+        <p:txBody>
+          <a:bodyPr wrap="square" lIns="0" tIns="0" rIns="0" bIns="0" rtlCol="0" anchor="ctr"/>
+          <a:lstStyle/>
+          <a:p>
+            <a:pPr marL="0" indent="0">
+              <a:buNone/>
+            </a:pPr>
+            <a:r>
+              <a:rPr lang="en-US" sz="1050" dirty="0">
+                <a:solidFill>
+                  <a:srgbClr val="5C6B76"/>
+                </a:solidFill>
+                <a:latin typeface="Calibri" pitchFamily="34" charset="0"/>
+                <a:ea typeface="Calibri" pitchFamily="34" charset="-122"/>
+                <a:cs typeface="Calibri" pitchFamily="34" charset="-120"/>
+              </a:rPr>
+              <a:t>Stretch ripstop, built for heat</a:t>
+            </a:r>
+            <a:endParaRPr lang="en-US" sz="1050" dirty="0"/>
+          </a:p>
+        </p:txBody>
+      </p:sp>
+      <p:sp>
+        <p:nvSpPr>
+          <p:cNvPr id="29" name="Text 26"/>
+          <p:cNvSpPr/>
+          <p:nvPr/>
+        </p:nvSpPr>
+        <p:spPr>
+          <a:xfrm>
+            <a:off x="1243584" y="4224528"/>
+            <a:ext cx="4517136" cy="182880"/>
+          </a:xfrm>
+          <a:prstGeom prst="rect">
+            <a:avLst/>
+          </a:prstGeom>
+          <a:noFill/>
+          <a:ln/>
+        </p:spPr>
+        <p:txBody>
+          <a:bodyPr wrap="square" lIns="0" tIns="0" rIns="0" bIns="0" rtlCol="0" anchor="ctr"/>
+          <a:lstStyle/>
+          <a:p>
+            <a:pPr marL="0" indent="0">
+              <a:buNone/>
+            </a:pPr>
+            <a:r>
+              <a:rPr lang="en-US" sz="850" b="1" kern="0" spc="50" dirty="0">
+                <a:solidFill>
+                  <a:srgbClr val="9A6212"/>
+                </a:solidFill>
+                <a:latin typeface="Arial" pitchFamily="34" charset="0"/>
+                <a:ea typeface="Arial" pitchFamily="34" charset="-122"/>
+                <a:cs typeface="Arial" pitchFamily="34" charset="-120"/>
+              </a:rPr>
+              <a:t>NEWEST LAUNCH · own page</a:t>
+            </a:r>
+            <a:endParaRPr lang="en-US" sz="850" dirty="0"/>
+          </a:p>
+        </p:txBody>
+      </p:sp>
+      <p:sp>
+        <p:nvSpPr>
+          <p:cNvPr id="30" name="Shape 27"/>
+          <p:cNvSpPr/>
+          <p:nvPr/>
+        </p:nvSpPr>
+        <p:spPr>
+          <a:xfrm>
+            <a:off x="457200" y="4544568"/>
+            <a:ext cx="5486400" cy="758952"/>
+          </a:xfrm>
+          <a:prstGeom prst="roundRect">
+            <a:avLst>
+              <a:gd name="adj" fmla="val 7229"/>
+            </a:avLst>
+          </a:prstGeom>
+          <a:solidFill>
+            <a:srgbClr val="F3F5F6"/>
+          </a:solidFill>
+          <a:ln/>
+          <a:effectLst>
+            <a:outerShdw blurRad="88900" dist="25400" dir="5400000" algn="bl" rotWithShape="0">
+              <a:srgbClr val="000000">
+                <a:alpha val="13000"/>
+              </a:srgbClr>
+            </a:outerShdw>
+          </a:effectLst>
+        </p:spPr>
+      </p:sp>
+      <p:sp>
+        <p:nvSpPr>
+          <p:cNvPr id="31" name="Shape 28"/>
+          <p:cNvSpPr/>
+          <p:nvPr/>
+        </p:nvSpPr>
+        <p:spPr>
+          <a:xfrm>
+            <a:off x="621792" y="4700016"/>
+            <a:ext cx="457200" cy="457200"/>
+          </a:xfrm>
+          <a:prstGeom prst="ellipse">
+            <a:avLst/>
+          </a:prstGeom>
+          <a:solidFill>
+            <a:srgbClr val="2B3640"/>
+          </a:solidFill>
+          <a:ln/>
+        </p:spPr>
+      </p:sp>
+      <p:sp>
+        <p:nvSpPr>
+          <p:cNvPr id="32" name="Text 29"/>
+          <p:cNvSpPr/>
+          <p:nvPr/>
+        </p:nvSpPr>
+        <p:spPr>
+          <a:xfrm>
+            <a:off x="621792" y="4700016"/>
+            <a:ext cx="457200" cy="457200"/>
+          </a:xfrm>
+          <a:prstGeom prst="rect">
+            <a:avLst/>
+          </a:prstGeom>
+          <a:noFill/>
+          <a:ln/>
+        </p:spPr>
+        <p:txBody>
+          <a:bodyPr wrap="square" lIns="0" tIns="0" rIns="0" bIns="0" rtlCol="0" anchor="ctr"/>
+          <a:lstStyle/>
+          <a:p>
+            <a:pPr marL="0" indent="0" algn="ctr">
+              <a:buNone/>
+            </a:pPr>
+            <a:r>
+              <a:rPr lang="en-US" sz="1800" b="1" dirty="0">
+                <a:solidFill>
+                  <a:srgbClr val="DD841C"/>
+                </a:solidFill>
+                <a:latin typeface="Arial" pitchFamily="34" charset="0"/>
+                <a:ea typeface="Arial" pitchFamily="34" charset="-122"/>
+                <a:cs typeface="Arial" pitchFamily="34" charset="-120"/>
+              </a:rPr>
+              <a:t>4</a:t>
+            </a:r>
+            <a:endParaRPr lang="en-US" sz="1800" dirty="0"/>
+          </a:p>
+        </p:txBody>
+      </p:sp>
+      <p:sp>
+        <p:nvSpPr>
+          <p:cNvPr id="33" name="Text 30"/>
+          <p:cNvSpPr/>
+          <p:nvPr/>
+        </p:nvSpPr>
+        <p:spPr>
+          <a:xfrm>
+            <a:off x="1243584" y="4626864"/>
+            <a:ext cx="3328416" cy="256032"/>
+          </a:xfrm>
+          <a:prstGeom prst="rect">
+            <a:avLst/>
+          </a:prstGeom>
+          <a:noFill/>
+          <a:ln/>
+        </p:spPr>
+        <p:txBody>
+          <a:bodyPr wrap="square" lIns="0" tIns="0" rIns="0" bIns="0" rtlCol="0" anchor="ctr"/>
+          <a:lstStyle/>
+          <a:p>
+            <a:pPr marL="0" indent="0">
+              <a:buNone/>
+            </a:pPr>
+            <a:r>
+              <a:rPr lang="en-US" sz="1400" b="1" dirty="0">
+                <a:solidFill>
+                  <a:srgbClr val="20292F"/>
+                </a:solidFill>
+                <a:latin typeface="Arial" pitchFamily="34" charset="0"/>
+                <a:ea typeface="Arial" pitchFamily="34" charset="-122"/>
+                <a:cs typeface="Arial" pitchFamily="34" charset="-120"/>
+              </a:rPr>
+              <a:t>e.s.vintage</a:t>
+            </a:r>
+            <a:endParaRPr lang="en-US" sz="1400" dirty="0"/>
+          </a:p>
+        </p:txBody>
+      </p:sp>
+      <p:sp>
+        <p:nvSpPr>
+          <p:cNvPr id="34" name="Text 31"/>
+          <p:cNvSpPr/>
+          <p:nvPr/>
+        </p:nvSpPr>
+        <p:spPr>
+          <a:xfrm>
+            <a:off x="4572000" y="4626864"/>
+            <a:ext cx="1188720" cy="256032"/>
+          </a:xfrm>
+          <a:prstGeom prst="rect">
+            <a:avLst/>
+          </a:prstGeom>
+          <a:noFill/>
+          <a:ln/>
+        </p:spPr>
+        <p:txBody>
+          <a:bodyPr wrap="square" lIns="0" tIns="0" rIns="0" bIns="0" rtlCol="0" anchor="ctr"/>
+          <a:lstStyle/>
+          <a:p>
+            <a:pPr marL="0" indent="0" algn="r">
+              <a:buNone/>
+            </a:pPr>
+            <a:r>
+              <a:rPr lang="en-US" sz="1300" b="1" dirty="0">
+                <a:solidFill>
+                  <a:srgbClr val="DD841C"/>
+                </a:solidFill>
+                <a:latin typeface="Arial" pitchFamily="34" charset="0"/>
+                <a:ea typeface="Arial" pitchFamily="34" charset="-122"/>
+                <a:cs typeface="Arial" pitchFamily="34" charset="-120"/>
+              </a:rPr>
+              <a:t>$120–130</a:t>
+            </a:r>
+            <a:endParaRPr lang="en-US" sz="1300" dirty="0"/>
+          </a:p>
+        </p:txBody>
+      </p:sp>
+      <p:sp>
+        <p:nvSpPr>
+          <p:cNvPr id="35" name="Text 32"/>
+          <p:cNvSpPr/>
+          <p:nvPr/>
+        </p:nvSpPr>
+        <p:spPr>
+          <a:xfrm>
+            <a:off x="1243584" y="4882896"/>
+            <a:ext cx="4517136" cy="201168"/>
+          </a:xfrm>
+          <a:prstGeom prst="rect">
+            <a:avLst/>
+          </a:prstGeom>
+          <a:noFill/>
+          <a:ln/>
+        </p:spPr>
+        <p:txBody>
+          <a:bodyPr wrap="square" lIns="0" tIns="0" rIns="0" bIns="0" rtlCol="0" anchor="ctr"/>
+          <a:lstStyle/>
+          <a:p>
+            <a:pPr marL="0" indent="0">
+              <a:buNone/>
+            </a:pPr>
+            <a:r>
+              <a:rPr lang="en-US" sz="1050" dirty="0">
+                <a:solidFill>
+                  <a:srgbClr val="5C6B76"/>
+                </a:solidFill>
+                <a:latin typeface="Calibri" pitchFamily="34" charset="0"/>
+                <a:ea typeface="Calibri" pitchFamily="34" charset="-122"/>
+                <a:cs typeface="Calibri" pitchFamily="34" charset="-120"/>
+              </a:rPr>
+              <a:t>Canvas multipocket bibs &amp; pants</a:t>
+            </a:r>
+            <a:endParaRPr lang="en-US" sz="1050" dirty="0"/>
+          </a:p>
+        </p:txBody>
+      </p:sp>
+      <p:sp>
+        <p:nvSpPr>
+          <p:cNvPr id="36" name="Text 33"/>
+          <p:cNvSpPr/>
+          <p:nvPr/>
+        </p:nvSpPr>
+        <p:spPr>
+          <a:xfrm>
+            <a:off x="1243584" y="5074920"/>
+            <a:ext cx="4517136" cy="182880"/>
+          </a:xfrm>
+          <a:prstGeom prst="rect">
+            <a:avLst/>
+          </a:prstGeom>
+          <a:noFill/>
+          <a:ln/>
+        </p:spPr>
+        <p:txBody>
+          <a:bodyPr wrap="square" lIns="0" tIns="0" rIns="0" bIns="0" rtlCol="0" anchor="ctr"/>
+          <a:lstStyle/>
+          <a:p>
+            <a:pPr marL="0" indent="0">
+              <a:buNone/>
+            </a:pPr>
+            <a:r>
+              <a:rPr lang="en-US" sz="850" b="1" kern="0" spc="50" dirty="0">
+                <a:solidFill>
+                  <a:srgbClr val="9A6212"/>
+                </a:solidFill>
+                <a:latin typeface="Arial" pitchFamily="34" charset="0"/>
+                <a:ea typeface="Arial" pitchFamily="34" charset="-122"/>
+                <a:cs typeface="Arial" pitchFamily="34" charset="-120"/>
+              </a:rPr>
+              <a:t>TOP SELLER bib</a:t>
+            </a:r>
+            <a:endParaRPr lang="en-US" sz="850" dirty="0"/>
+          </a:p>
+        </p:txBody>
+      </p:sp>
+      <p:sp>
+        <p:nvSpPr>
+          <p:cNvPr id="37" name="Shape 34"/>
+          <p:cNvSpPr/>
+          <p:nvPr/>
+        </p:nvSpPr>
+        <p:spPr>
+          <a:xfrm>
+            <a:off x="457200" y="5394960"/>
+            <a:ext cx="5486400" cy="758952"/>
+          </a:xfrm>
+          <a:prstGeom prst="roundRect">
+            <a:avLst>
+              <a:gd name="adj" fmla="val 7229"/>
+            </a:avLst>
+          </a:prstGeom>
+          <a:solidFill>
+            <a:srgbClr val="F3F5F6"/>
+          </a:solidFill>
+          <a:ln/>
+          <a:effectLst>
+            <a:outerShdw blurRad="88900" dist="25400" dir="5400000" algn="bl" rotWithShape="0">
+              <a:srgbClr val="000000">
+                <a:alpha val="13000"/>
+              </a:srgbClr>
+            </a:outerShdw>
+          </a:effectLst>
+        </p:spPr>
+      </p:sp>
+      <p:sp>
+        <p:nvSpPr>
+          <p:cNvPr id="38" name="Shape 35"/>
+          <p:cNvSpPr/>
+          <p:nvPr/>
+        </p:nvSpPr>
+        <p:spPr>
+          <a:xfrm>
+            <a:off x="621792" y="5550408"/>
+            <a:ext cx="457200" cy="457200"/>
+          </a:xfrm>
+          <a:prstGeom prst="ellipse">
+            <a:avLst/>
+          </a:prstGeom>
+          <a:solidFill>
+            <a:srgbClr val="2B3640"/>
+          </a:solidFill>
+          <a:ln/>
+        </p:spPr>
+      </p:sp>
+      <p:sp>
+        <p:nvSpPr>
+          <p:cNvPr id="39" name="Text 36"/>
+          <p:cNvSpPr/>
+          <p:nvPr/>
+        </p:nvSpPr>
+        <p:spPr>
+          <a:xfrm>
+            <a:off x="621792" y="5550408"/>
+            <a:ext cx="457200" cy="457200"/>
+          </a:xfrm>
+          <a:prstGeom prst="rect">
+            <a:avLst/>
+          </a:prstGeom>
+          <a:noFill/>
+          <a:ln/>
+        </p:spPr>
+        <p:txBody>
+          <a:bodyPr wrap="square" lIns="0" tIns="0" rIns="0" bIns="0" rtlCol="0" anchor="ctr"/>
+          <a:lstStyle/>
+          <a:p>
+            <a:pPr marL="0" indent="0" algn="ctr">
+              <a:buNone/>
+            </a:pPr>
+            <a:r>
+              <a:rPr lang="en-US" sz="1800" b="1" dirty="0">
+                <a:solidFill>
+                  <a:srgbClr val="DD841C"/>
+                </a:solidFill>
+                <a:latin typeface="Arial" pitchFamily="34" charset="0"/>
+                <a:ea typeface="Arial" pitchFamily="34" charset="-122"/>
+                <a:cs typeface="Arial" pitchFamily="34" charset="-120"/>
+              </a:rPr>
+              <a:t>5</a:t>
+            </a:r>
+            <a:endParaRPr lang="en-US" sz="1800" dirty="0"/>
+          </a:p>
+        </p:txBody>
+      </p:sp>
+      <p:sp>
+        <p:nvSpPr>
+          <p:cNvPr id="40" name="Text 37"/>
+          <p:cNvSpPr/>
+          <p:nvPr/>
+        </p:nvSpPr>
+        <p:spPr>
+          <a:xfrm>
+            <a:off x="1243584" y="5477256"/>
+            <a:ext cx="3328416" cy="256032"/>
+          </a:xfrm>
+          <a:prstGeom prst="rect">
+            <a:avLst/>
+          </a:prstGeom>
+          <a:noFill/>
+          <a:ln/>
+        </p:spPr>
+        <p:txBody>
+          <a:bodyPr wrap="square" lIns="0" tIns="0" rIns="0" bIns="0" rtlCol="0" anchor="ctr"/>
+          <a:lstStyle/>
+          <a:p>
+            <a:pPr marL="0" indent="0">
+              <a:buNone/>
+            </a:pPr>
+            <a:r>
+              <a:rPr lang="en-US" sz="1400" b="1" dirty="0">
+                <a:solidFill>
+                  <a:srgbClr val="20292F"/>
+                </a:solidFill>
+                <a:latin typeface="Arial" pitchFamily="34" charset="0"/>
+                <a:ea typeface="Arial" pitchFamily="34" charset="-122"/>
+                <a:cs typeface="Arial" pitchFamily="34" charset="-120"/>
+              </a:rPr>
+              <a:t>e.s.iconic</a:t>
+            </a:r>
+            <a:endParaRPr lang="en-US" sz="1400" dirty="0"/>
+          </a:p>
+        </p:txBody>
+      </p:sp>
+      <p:sp>
+        <p:nvSpPr>
+          <p:cNvPr id="41" name="Text 38"/>
+          <p:cNvSpPr/>
+          <p:nvPr/>
+        </p:nvSpPr>
+        <p:spPr>
+          <a:xfrm>
+            <a:off x="4572000" y="5477256"/>
+            <a:ext cx="1188720" cy="256032"/>
+          </a:xfrm>
+          <a:prstGeom prst="rect">
+            <a:avLst/>
+          </a:prstGeom>
+          <a:noFill/>
+          <a:ln/>
+        </p:spPr>
+        <p:txBody>
+          <a:bodyPr wrap="square" lIns="0" tIns="0" rIns="0" bIns="0" rtlCol="0" anchor="ctr"/>
+          <a:lstStyle/>
+          <a:p>
+            <a:pPr marL="0" indent="0" algn="r">
+              <a:buNone/>
+            </a:pPr>
+            <a:r>
+              <a:rPr lang="en-US" sz="1300" b="1" dirty="0">
+                <a:solidFill>
+                  <a:srgbClr val="DD841C"/>
+                </a:solidFill>
+                <a:latin typeface="Arial" pitchFamily="34" charset="0"/>
+                <a:ea typeface="Arial" pitchFamily="34" charset="-122"/>
+                <a:cs typeface="Arial" pitchFamily="34" charset="-120"/>
+              </a:rPr>
+              <a:t>$80–90</a:t>
+            </a:r>
+            <a:endParaRPr lang="en-US" sz="1300" dirty="0"/>
+          </a:p>
+        </p:txBody>
+      </p:sp>
+      <p:sp>
+        <p:nvSpPr>
+          <p:cNvPr id="42" name="Text 39"/>
+          <p:cNvSpPr/>
+          <p:nvPr/>
+        </p:nvSpPr>
+        <p:spPr>
+          <a:xfrm>
+            <a:off x="1243584" y="5733288"/>
+            <a:ext cx="4517136" cy="201168"/>
+          </a:xfrm>
+          <a:prstGeom prst="rect">
+            <a:avLst/>
+          </a:prstGeom>
+          <a:noFill/>
+          <a:ln/>
+        </p:spPr>
+        <p:txBody>
+          <a:bodyPr wrap="square" lIns="0" tIns="0" rIns="0" bIns="0" rtlCol="0" anchor="ctr"/>
+          <a:lstStyle/>
+          <a:p>
+            <a:pPr marL="0" indent="0">
+              <a:buNone/>
+            </a:pPr>
+            <a:r>
+              <a:rPr lang="en-US" sz="1050" dirty="0">
+                <a:solidFill>
+                  <a:srgbClr val="5C6B76"/>
+                </a:solidFill>
+                <a:latin typeface="Calibri" pitchFamily="34" charset="0"/>
+                <a:ea typeface="Calibri" pitchFamily="34" charset="-122"/>
+                <a:cs typeface="Calibri" pitchFamily="34" charset="-120"/>
+              </a:rPr>
+              <a:t>Tool vests &amp; value work pants</a:t>
+            </a:r>
+            <a:endParaRPr lang="en-US" sz="1050" dirty="0"/>
+          </a:p>
+        </p:txBody>
+      </p:sp>
+      <p:sp>
+        <p:nvSpPr>
+          <p:cNvPr id="43" name="Text 40"/>
+          <p:cNvSpPr/>
+          <p:nvPr/>
+        </p:nvSpPr>
+        <p:spPr>
+          <a:xfrm>
+            <a:off x="1243584" y="5925312"/>
+            <a:ext cx="4517136" cy="182880"/>
+          </a:xfrm>
+          <a:prstGeom prst="rect">
+            <a:avLst/>
+          </a:prstGeom>
+          <a:noFill/>
+          <a:ln/>
+        </p:spPr>
+        <p:txBody>
+          <a:bodyPr wrap="square" lIns="0" tIns="0" rIns="0" bIns="0" rtlCol="0" anchor="ctr"/>
+          <a:lstStyle/>
+          <a:p>
+            <a:pPr marL="0" indent="0">
+              <a:buNone/>
+            </a:pPr>
+            <a:r>
+              <a:rPr lang="en-US" sz="850" b="1" kern="0" spc="50" dirty="0">
+                <a:solidFill>
+                  <a:srgbClr val="9A6212"/>
+                </a:solidFill>
+                <a:latin typeface="Arial" pitchFamily="34" charset="0"/>
+                <a:ea typeface="Arial" pitchFamily="34" charset="-122"/>
+                <a:cs typeface="Arial" pitchFamily="34" charset="-120"/>
+              </a:rPr>
+              <a:t>STRAUSS PICK</a:t>
+            </a:r>
+            <a:endParaRPr lang="en-US" sz="850" dirty="0"/>
+          </a:p>
+        </p:txBody>
+      </p:sp>
+      <p:sp>
+        <p:nvSpPr>
+          <p:cNvPr id="44" name="Shape 41"/>
+          <p:cNvSpPr/>
+          <p:nvPr/>
+        </p:nvSpPr>
+        <p:spPr>
+          <a:xfrm>
+            <a:off x="6245352" y="1389888"/>
+            <a:ext cx="457200" cy="457200"/>
+          </a:xfrm>
+          <a:prstGeom prst="ellipse">
+            <a:avLst/>
+          </a:prstGeom>
+          <a:solidFill>
+            <a:srgbClr val="DD841C"/>
+          </a:solidFill>
+          <a:ln/>
+        </p:spPr>
+      </p:sp>
+      <p:pic>
+        <p:nvPicPr>
+          <p:cNvPr id="45" name="Image 1" descr="preencoded.png"/>
+          <p:cNvPicPr>
+            <a:picLocks noChangeAspect="1"/>
+          </p:cNvPicPr>
+          <p:nvPr/>
+        </p:nvPicPr>
+        <p:blipFill>
+          <a:blip r:embed="rId4"/>
+          <a:stretch>
+            <a:fillRect/>
+          </a:stretch>
+        </p:blipFill>
+        <p:spPr>
+          <a:xfrm>
+            <a:off x="6400800" y="1481328"/>
+            <a:ext cx="164592" cy="274320"/>
+          </a:xfrm>
+          <a:prstGeom prst="rect">
+            <a:avLst/>
+          </a:prstGeom>
+        </p:spPr>
+      </p:pic>
+      <p:sp>
+        <p:nvSpPr>
+          <p:cNvPr id="46" name="Text 42"/>
+          <p:cNvSpPr/>
+          <p:nvPr/>
+        </p:nvSpPr>
+        <p:spPr>
+          <a:xfrm>
+            <a:off x="6812280" y="1389888"/>
+            <a:ext cx="4919472" cy="457200"/>
+          </a:xfrm>
+          <a:prstGeom prst="rect">
+            <a:avLst/>
+          </a:prstGeom>
+          <a:noFill/>
+          <a:ln/>
+        </p:spPr>
+        <p:txBody>
+          <a:bodyPr wrap="square" lIns="0" tIns="0" rIns="0" bIns="0" rtlCol="0" anchor="ctr"/>
+          <a:lstStyle/>
+          <a:p>
+            <a:pPr marL="0" indent="0">
+              <a:buNone/>
+            </a:pPr>
+            <a:r>
+              <a:rPr lang="en-US" sz="1800" b="1" dirty="0">
+                <a:solidFill>
+                  <a:srgbClr val="2B3640"/>
+                </a:solidFill>
+                <a:latin typeface="Arial" pitchFamily="34" charset="0"/>
+                <a:ea typeface="Arial" pitchFamily="34" charset="-122"/>
+                <a:cs typeface="Arial" pitchFamily="34" charset="-120"/>
+              </a:rPr>
+              <a:t>WOMEN</a:t>
+            </a:r>
+            <a:endParaRPr lang="en-US" sz="1800" dirty="0"/>
+          </a:p>
+        </p:txBody>
+      </p:sp>
+      <p:sp>
+        <p:nvSpPr>
+          <p:cNvPr id="47" name="Shape 43"/>
+          <p:cNvSpPr/>
+          <p:nvPr/>
+        </p:nvSpPr>
+        <p:spPr>
+          <a:xfrm>
+            <a:off x="6245352" y="1993392"/>
+            <a:ext cx="5486400" cy="758952"/>
+          </a:xfrm>
+          <a:prstGeom prst="roundRect">
+            <a:avLst>
+              <a:gd name="adj" fmla="val 7229"/>
+            </a:avLst>
+          </a:prstGeom>
+          <a:solidFill>
+            <a:srgbClr val="F3F5F6"/>
+          </a:solidFill>
+          <a:ln/>
+          <a:effectLst>
+            <a:outerShdw blurRad="88900" dist="25400" dir="5400000" algn="bl" rotWithShape="0">
+              <a:srgbClr val="000000">
+                <a:alpha val="13000"/>
+              </a:srgbClr>
+            </a:outerShdw>
+          </a:effectLst>
+        </p:spPr>
+      </p:sp>
+      <p:sp>
+        <p:nvSpPr>
+          <p:cNvPr id="48" name="Shape 44"/>
+          <p:cNvSpPr/>
+          <p:nvPr/>
+        </p:nvSpPr>
+        <p:spPr>
+          <a:xfrm>
+            <a:off x="6409944" y="2148840"/>
+            <a:ext cx="457200" cy="457200"/>
+          </a:xfrm>
+          <a:prstGeom prst="ellipse">
+            <a:avLst/>
+          </a:prstGeom>
+          <a:solidFill>
+            <a:srgbClr val="2B3640"/>
+          </a:solidFill>
+          <a:ln/>
+        </p:spPr>
+      </p:sp>
+      <p:sp>
+        <p:nvSpPr>
+          <p:cNvPr id="49" name="Text 45"/>
+          <p:cNvSpPr/>
+          <p:nvPr/>
+        </p:nvSpPr>
+        <p:spPr>
+          <a:xfrm>
+            <a:off x="6409944" y="2148840"/>
+            <a:ext cx="457200" cy="457200"/>
+          </a:xfrm>
+          <a:prstGeom prst="rect">
+            <a:avLst/>
+          </a:prstGeom>
+          <a:noFill/>
+          <a:ln/>
+        </p:spPr>
+        <p:txBody>
+          <a:bodyPr wrap="square" lIns="0" tIns="0" rIns="0" bIns="0" rtlCol="0" anchor="ctr"/>
+          <a:lstStyle/>
+          <a:p>
+            <a:pPr marL="0" indent="0" algn="ctr">
+              <a:buNone/>
+            </a:pPr>
+            <a:r>
+              <a:rPr lang="en-US" sz="1800" b="1" dirty="0">
+                <a:solidFill>
+                  <a:srgbClr val="DD841C"/>
+                </a:solidFill>
+                <a:latin typeface="Arial" pitchFamily="34" charset="0"/>
+                <a:ea typeface="Arial" pitchFamily="34" charset="-122"/>
+                <a:cs typeface="Arial" pitchFamily="34" charset="-120"/>
+              </a:rPr>
+              <a:t>1</a:t>
+            </a:r>
+            <a:endParaRPr lang="en-US" sz="1800" dirty="0"/>
+          </a:p>
+        </p:txBody>
+      </p:sp>
+      <p:sp>
+        <p:nvSpPr>
+          <p:cNvPr id="50" name="Text 46"/>
+          <p:cNvSpPr/>
+          <p:nvPr/>
+        </p:nvSpPr>
+        <p:spPr>
+          <a:xfrm>
+            <a:off x="7031736" y="2075688"/>
+            <a:ext cx="3328416" cy="256032"/>
+          </a:xfrm>
+          <a:prstGeom prst="rect">
+            <a:avLst/>
+          </a:prstGeom>
+          <a:noFill/>
+          <a:ln/>
+        </p:spPr>
+        <p:txBody>
+          <a:bodyPr wrap="square" lIns="0" tIns="0" rIns="0" bIns="0" rtlCol="0" anchor="ctr"/>
+          <a:lstStyle/>
+          <a:p>
+            <a:pPr marL="0" indent="0">
+              <a:buNone/>
+            </a:pPr>
+            <a:r>
+              <a:rPr lang="en-US" sz="1400" b="1" dirty="0">
+                <a:solidFill>
+                  <a:srgbClr val="20292F"/>
+                </a:solidFill>
+                <a:latin typeface="Arial" pitchFamily="34" charset="0"/>
+                <a:ea typeface="Arial" pitchFamily="34" charset="-122"/>
+                <a:cs typeface="Arial" pitchFamily="34" charset="-120"/>
+              </a:rPr>
+              <a:t>e.s.motion ten</a:t>
+            </a:r>
+            <a:endParaRPr lang="en-US" sz="1400" dirty="0"/>
+          </a:p>
+        </p:txBody>
+      </p:sp>
+      <p:sp>
+        <p:nvSpPr>
+          <p:cNvPr id="51" name="Text 47"/>
+          <p:cNvSpPr/>
+          <p:nvPr/>
+        </p:nvSpPr>
+        <p:spPr>
+          <a:xfrm>
+            <a:off x="10360152" y="2075688"/>
+            <a:ext cx="1188720" cy="256032"/>
+          </a:xfrm>
+          <a:prstGeom prst="rect">
+            <a:avLst/>
+          </a:prstGeom>
+          <a:noFill/>
+          <a:ln/>
+        </p:spPr>
+        <p:txBody>
+          <a:bodyPr wrap="square" lIns="0" tIns="0" rIns="0" bIns="0" rtlCol="0" anchor="ctr"/>
+          <a:lstStyle/>
+          <a:p>
+            <a:pPr marL="0" indent="0" algn="r">
+              <a:buNone/>
+            </a:pPr>
+            <a:r>
+              <a:rPr lang="en-US" sz="1300" b="1" dirty="0">
+                <a:solidFill>
+                  <a:srgbClr val="DD841C"/>
+                </a:solidFill>
+                <a:latin typeface="Arial" pitchFamily="34" charset="0"/>
+                <a:ea typeface="Arial" pitchFamily="34" charset="-122"/>
+                <a:cs typeface="Arial" pitchFamily="34" charset="-120"/>
+              </a:rPr>
+              <a:t>$99–169</a:t>
+            </a:r>
+            <a:endParaRPr lang="en-US" sz="1300" dirty="0"/>
+          </a:p>
+        </p:txBody>
+      </p:sp>
+      <p:sp>
+        <p:nvSpPr>
+          <p:cNvPr id="52" name="Text 48"/>
+          <p:cNvSpPr/>
+          <p:nvPr/>
+        </p:nvSpPr>
+        <p:spPr>
+          <a:xfrm>
+            <a:off x="7031736" y="2331720"/>
+            <a:ext cx="4517136" cy="201168"/>
+          </a:xfrm>
+          <a:prstGeom prst="rect">
+            <a:avLst/>
+          </a:prstGeom>
+          <a:noFill/>
+          <a:ln/>
+        </p:spPr>
+        <p:txBody>
+          <a:bodyPr wrap="square" lIns="0" tIns="0" rIns="0" bIns="0" rtlCol="0" anchor="ctr"/>
+          <a:lstStyle/>
+          <a:p>
+            <a:pPr marL="0" indent="0">
+              <a:buNone/>
+            </a:pPr>
+            <a:r>
+              <a:rPr lang="en-US" sz="1050" dirty="0">
+                <a:solidFill>
+                  <a:srgbClr val="5C6B76"/>
+                </a:solidFill>
+                <a:latin typeface="Calibri" pitchFamily="34" charset="0"/>
+                <a:ea typeface="Calibri" pitchFamily="34" charset="-122"/>
+                <a:cs typeface="Calibri" pitchFamily="34" charset="-120"/>
+              </a:rPr>
+              <a:t>Cargo pants, vests, hybrid jackets</a:t>
+            </a:r>
+            <a:endParaRPr lang="en-US" sz="1050" dirty="0"/>
+          </a:p>
+        </p:txBody>
+      </p:sp>
+      <p:sp>
+        <p:nvSpPr>
+          <p:cNvPr id="53" name="Text 49"/>
+          <p:cNvSpPr/>
+          <p:nvPr/>
+        </p:nvSpPr>
+        <p:spPr>
+          <a:xfrm>
+            <a:off x="7031736" y="2523744"/>
+            <a:ext cx="4517136" cy="182880"/>
+          </a:xfrm>
+          <a:prstGeom prst="rect">
+            <a:avLst/>
+          </a:prstGeom>
+          <a:noFill/>
+          <a:ln/>
+        </p:spPr>
+        <p:txBody>
+          <a:bodyPr wrap="square" lIns="0" tIns="0" rIns="0" bIns="0" rtlCol="0" anchor="ctr"/>
+          <a:lstStyle/>
+          <a:p>
+            <a:pPr marL="0" indent="0">
+              <a:buNone/>
+            </a:pPr>
+            <a:r>
+              <a:rPr lang="en-US" sz="850" b="1" kern="0" spc="50" dirty="0">
+                <a:solidFill>
+                  <a:srgbClr val="9A6212"/>
+                </a:solidFill>
+                <a:latin typeface="Arial" pitchFamily="34" charset="0"/>
+                <a:ea typeface="Arial" pitchFamily="34" charset="-122"/>
+                <a:cs typeface="Arial" pitchFamily="34" charset="-120"/>
+              </a:rPr>
+              <a:t>#1 BEST-SELLER slot</a:t>
+            </a:r>
+            <a:endParaRPr lang="en-US" sz="850" dirty="0"/>
+          </a:p>
+        </p:txBody>
+      </p:sp>
+      <p:sp>
+        <p:nvSpPr>
+          <p:cNvPr id="54" name="Shape 50"/>
+          <p:cNvSpPr/>
+          <p:nvPr/>
+        </p:nvSpPr>
+        <p:spPr>
+          <a:xfrm>
+            <a:off x="6245352" y="2843784"/>
+            <a:ext cx="5486400" cy="758952"/>
+          </a:xfrm>
+          <a:prstGeom prst="roundRect">
+            <a:avLst>
+              <a:gd name="adj" fmla="val 7229"/>
+            </a:avLst>
+          </a:prstGeom>
+          <a:solidFill>
+            <a:srgbClr val="F3F5F6"/>
+          </a:solidFill>
+          <a:ln/>
+          <a:effectLst>
+            <a:outerShdw blurRad="88900" dist="25400" dir="5400000" algn="bl" rotWithShape="0">
+              <a:srgbClr val="000000">
+                <a:alpha val="13000"/>
+              </a:srgbClr>
+            </a:outerShdw>
+          </a:effectLst>
+        </p:spPr>
+      </p:sp>
+      <p:sp>
+        <p:nvSpPr>
+          <p:cNvPr id="55" name="Shape 51"/>
+          <p:cNvSpPr/>
+          <p:nvPr/>
+        </p:nvSpPr>
+        <p:spPr>
+          <a:xfrm>
+            <a:off x="6409944" y="2999232"/>
+            <a:ext cx="457200" cy="457200"/>
+          </a:xfrm>
+          <a:prstGeom prst="ellipse">
+            <a:avLst/>
+          </a:prstGeom>
+          <a:solidFill>
+            <a:srgbClr val="2B3640"/>
+          </a:solidFill>
+          <a:ln/>
+        </p:spPr>
+      </p:sp>
+      <p:sp>
+        <p:nvSpPr>
+          <p:cNvPr id="56" name="Text 52"/>
+          <p:cNvSpPr/>
+          <p:nvPr/>
+        </p:nvSpPr>
+        <p:spPr>
+          <a:xfrm>
+            <a:off x="6409944" y="2999232"/>
+            <a:ext cx="457200" cy="457200"/>
+          </a:xfrm>
+          <a:prstGeom prst="rect">
+            <a:avLst/>
+          </a:prstGeom>
+          <a:noFill/>
+          <a:ln/>
+        </p:spPr>
+        <p:txBody>
+          <a:bodyPr wrap="square" lIns="0" tIns="0" rIns="0" bIns="0" rtlCol="0" anchor="ctr"/>
+          <a:lstStyle/>
+          <a:p>
+            <a:pPr marL="0" indent="0" algn="ctr">
+              <a:buNone/>
+            </a:pPr>
+            <a:r>
+              <a:rPr lang="en-US" sz="1800" b="1" dirty="0">
+                <a:solidFill>
+                  <a:srgbClr val="DD841C"/>
+                </a:solidFill>
+                <a:latin typeface="Arial" pitchFamily="34" charset="0"/>
+                <a:ea typeface="Arial" pitchFamily="34" charset="-122"/>
+                <a:cs typeface="Arial" pitchFamily="34" charset="-120"/>
+              </a:rPr>
+              <a:t>2</a:t>
+            </a:r>
+            <a:endParaRPr lang="en-US" sz="1800" dirty="0"/>
+          </a:p>
+        </p:txBody>
+      </p:sp>
+      <p:sp>
+        <p:nvSpPr>
+          <p:cNvPr id="57" name="Text 53"/>
+          <p:cNvSpPr/>
+          <p:nvPr/>
+        </p:nvSpPr>
+        <p:spPr>
+          <a:xfrm>
+            <a:off x="7031736" y="2926080"/>
+            <a:ext cx="3328416" cy="256032"/>
+          </a:xfrm>
+          <a:prstGeom prst="rect">
+            <a:avLst/>
+          </a:prstGeom>
+          <a:noFill/>
+          <a:ln/>
+        </p:spPr>
+        <p:txBody>
+          <a:bodyPr wrap="square" lIns="0" tIns="0" rIns="0" bIns="0" rtlCol="0" anchor="ctr"/>
+          <a:lstStyle/>
+          <a:p>
+            <a:pPr marL="0" indent="0">
+              <a:buNone/>
+            </a:pPr>
+            <a:r>
+              <a:rPr lang="en-US" sz="1400" b="1" dirty="0">
+                <a:solidFill>
+                  <a:srgbClr val="20292F"/>
+                </a:solidFill>
+                <a:latin typeface="Arial" pitchFamily="34" charset="0"/>
+                <a:ea typeface="Arial" pitchFamily="34" charset="-122"/>
+                <a:cs typeface="Arial" pitchFamily="34" charset="-120"/>
+              </a:rPr>
+              <a:t>e.s.vintage</a:t>
+            </a:r>
+            <a:endParaRPr lang="en-US" sz="1400" dirty="0"/>
+          </a:p>
+        </p:txBody>
+      </p:sp>
+      <p:sp>
+        <p:nvSpPr>
+          <p:cNvPr id="58" name="Text 54"/>
+          <p:cNvSpPr/>
+          <p:nvPr/>
+        </p:nvSpPr>
+        <p:spPr>
+          <a:xfrm>
+            <a:off x="10360152" y="2926080"/>
+            <a:ext cx="1188720" cy="256032"/>
+          </a:xfrm>
+          <a:prstGeom prst="rect">
+            <a:avLst/>
+          </a:prstGeom>
+          <a:noFill/>
+          <a:ln/>
+        </p:spPr>
+        <p:txBody>
+          <a:bodyPr wrap="square" lIns="0" tIns="0" rIns="0" bIns="0" rtlCol="0" anchor="ctr"/>
+          <a:lstStyle/>
+          <a:p>
+            <a:pPr marL="0" indent="0" algn="r">
+              <a:buNone/>
+            </a:pPr>
+            <a:r>
+              <a:rPr lang="en-US" sz="1300" b="1" dirty="0">
+                <a:solidFill>
+                  <a:srgbClr val="DD841C"/>
+                </a:solidFill>
+                <a:latin typeface="Arial" pitchFamily="34" charset="0"/>
+                <a:ea typeface="Arial" pitchFamily="34" charset="-122"/>
+                <a:cs typeface="Arial" pitchFamily="34" charset="-120"/>
+              </a:rPr>
+              <a:t>$89–99</a:t>
+            </a:r>
+            <a:endParaRPr lang="en-US" sz="1300" dirty="0"/>
+          </a:p>
+        </p:txBody>
+      </p:sp>
+      <p:sp>
+        <p:nvSpPr>
+          <p:cNvPr id="59" name="Text 55"/>
+          <p:cNvSpPr/>
+          <p:nvPr/>
+        </p:nvSpPr>
+        <p:spPr>
+          <a:xfrm>
+            <a:off x="7031736" y="3182112"/>
+            <a:ext cx="4517136" cy="201168"/>
+          </a:xfrm>
+          <a:prstGeom prst="rect">
+            <a:avLst/>
+          </a:prstGeom>
+          <a:noFill/>
+          <a:ln/>
+        </p:spPr>
+        <p:txBody>
+          <a:bodyPr wrap="square" lIns="0" tIns="0" rIns="0" bIns="0" rtlCol="0" anchor="ctr"/>
+          <a:lstStyle/>
+          <a:p>
+            <a:pPr marL="0" indent="0">
+              <a:buNone/>
+            </a:pPr>
+            <a:r>
+              <a:rPr lang="en-US" sz="1050" dirty="0">
+                <a:solidFill>
+                  <a:srgbClr val="5C6B76"/>
+                </a:solidFill>
+                <a:latin typeface="Calibri" pitchFamily="34" charset="0"/>
+                <a:ea typeface="Calibri" pitchFamily="34" charset="-122"/>
+                <a:cs typeface="Calibri" pitchFamily="34" charset="-120"/>
+              </a:rPr>
+              <a:t>Canvas bibs &amp; multipocket pants</a:t>
+            </a:r>
+            <a:endParaRPr lang="en-US" sz="1050" dirty="0"/>
+          </a:p>
+        </p:txBody>
+      </p:sp>
+      <p:sp>
+        <p:nvSpPr>
+          <p:cNvPr id="60" name="Text 56"/>
+          <p:cNvSpPr/>
+          <p:nvPr/>
+        </p:nvSpPr>
+        <p:spPr>
+          <a:xfrm>
+            <a:off x="7031736" y="3374136"/>
+            <a:ext cx="4517136" cy="182880"/>
+          </a:xfrm>
+          <a:prstGeom prst="rect">
+            <a:avLst/>
+          </a:prstGeom>
+          <a:noFill/>
+          <a:ln/>
+        </p:spPr>
+        <p:txBody>
+          <a:bodyPr wrap="square" lIns="0" tIns="0" rIns="0" bIns="0" rtlCol="0" anchor="ctr"/>
+          <a:lstStyle/>
+          <a:p>
+            <a:pPr marL="0" indent="0">
+              <a:buNone/>
+            </a:pPr>
+            <a:r>
+              <a:rPr lang="en-US" sz="850" b="1" kern="0" spc="50" dirty="0">
+                <a:solidFill>
+                  <a:srgbClr val="9A6212"/>
+                </a:solidFill>
+                <a:latin typeface="Arial" pitchFamily="34" charset="0"/>
+                <a:ea typeface="Arial" pitchFamily="34" charset="-122"/>
+                <a:cs typeface="Arial" pitchFamily="34" charset="-120"/>
+              </a:rPr>
+              <a:t>TOP SELLER · most colors</a:t>
+            </a:r>
+            <a:endParaRPr lang="en-US" sz="850" dirty="0"/>
+          </a:p>
+        </p:txBody>
+      </p:sp>
+      <p:sp>
+        <p:nvSpPr>
+          <p:cNvPr id="61" name="Shape 57"/>
+          <p:cNvSpPr/>
+          <p:nvPr/>
+        </p:nvSpPr>
+        <p:spPr>
+          <a:xfrm>
+            <a:off x="6245352" y="3694176"/>
+            <a:ext cx="5486400" cy="758952"/>
+          </a:xfrm>
+          <a:prstGeom prst="roundRect">
+            <a:avLst>
+              <a:gd name="adj" fmla="val 7229"/>
+            </a:avLst>
+          </a:prstGeom>
+          <a:solidFill>
+            <a:srgbClr val="F3F5F6"/>
+          </a:solidFill>
+          <a:ln/>
+          <a:effectLst>
+            <a:outerShdw blurRad="88900" dist="25400" dir="5400000" algn="bl" rotWithShape="0">
+              <a:srgbClr val="000000">
+                <a:alpha val="13000"/>
+              </a:srgbClr>
+            </a:outerShdw>
+          </a:effectLst>
+        </p:spPr>
+      </p:sp>
+      <p:sp>
+        <p:nvSpPr>
+          <p:cNvPr id="62" name="Shape 58"/>
+          <p:cNvSpPr/>
+          <p:nvPr/>
+        </p:nvSpPr>
+        <p:spPr>
+          <a:xfrm>
+            <a:off x="6409944" y="3849624"/>
+            <a:ext cx="457200" cy="457200"/>
+          </a:xfrm>
+          <a:prstGeom prst="ellipse">
+            <a:avLst/>
+          </a:prstGeom>
+          <a:solidFill>
+            <a:srgbClr val="2B3640"/>
+          </a:solidFill>
+          <a:ln/>
+        </p:spPr>
+      </p:sp>
+      <p:sp>
+        <p:nvSpPr>
+          <p:cNvPr id="63" name="Text 59"/>
+          <p:cNvSpPr/>
+          <p:nvPr/>
+        </p:nvSpPr>
+        <p:spPr>
+          <a:xfrm>
+            <a:off x="6409944" y="3849624"/>
+            <a:ext cx="457200" cy="457200"/>
+          </a:xfrm>
+          <a:prstGeom prst="rect">
+            <a:avLst/>
+          </a:prstGeom>
+          <a:noFill/>
+          <a:ln/>
+        </p:spPr>
+        <p:txBody>
+          <a:bodyPr wrap="square" lIns="0" tIns="0" rIns="0" bIns="0" rtlCol="0" anchor="ctr"/>
+          <a:lstStyle/>
+          <a:p>
+            <a:pPr marL="0" indent="0" algn="ctr">
+              <a:buNone/>
+            </a:pPr>
+            <a:r>
+              <a:rPr lang="en-US" sz="1800" b="1" dirty="0">
+                <a:solidFill>
+                  <a:srgbClr val="DD841C"/>
+                </a:solidFill>
+                <a:latin typeface="Arial" pitchFamily="34" charset="0"/>
+                <a:ea typeface="Arial" pitchFamily="34" charset="-122"/>
+                <a:cs typeface="Arial" pitchFamily="34" charset="-120"/>
+              </a:rPr>
+              <a:t>3</a:t>
+            </a:r>
+            <a:endParaRPr lang="en-US" sz="1800" dirty="0"/>
+          </a:p>
+        </p:txBody>
+      </p:sp>
+      <p:sp>
+        <p:nvSpPr>
+          <p:cNvPr id="64" name="Text 60"/>
+          <p:cNvSpPr/>
+          <p:nvPr/>
+        </p:nvSpPr>
+        <p:spPr>
+          <a:xfrm>
+            <a:off x="7031736" y="3776472"/>
+            <a:ext cx="3328416" cy="256032"/>
+          </a:xfrm>
+          <a:prstGeom prst="rect">
+            <a:avLst/>
+          </a:prstGeom>
+          <a:noFill/>
+          <a:ln/>
+        </p:spPr>
+        <p:txBody>
+          <a:bodyPr wrap="square" lIns="0" tIns="0" rIns="0" bIns="0" rtlCol="0" anchor="ctr"/>
+          <a:lstStyle/>
+          <a:p>
+            <a:pPr marL="0" indent="0">
+              <a:buNone/>
+            </a:pPr>
+            <a:r>
+              <a:rPr lang="en-US" sz="1400" b="1" dirty="0">
+                <a:solidFill>
+                  <a:srgbClr val="20292F"/>
+                </a:solidFill>
+                <a:latin typeface="Arial" pitchFamily="34" charset="0"/>
+                <a:ea typeface="Arial" pitchFamily="34" charset="-122"/>
+                <a:cs typeface="Arial" pitchFamily="34" charset="-120"/>
+              </a:rPr>
+              <a:t>e.s.e:pic</a:t>
+            </a:r>
+            <a:endParaRPr lang="en-US" sz="1400" dirty="0"/>
+          </a:p>
+        </p:txBody>
+      </p:sp>
+      <p:sp>
+        <p:nvSpPr>
+          <p:cNvPr id="65" name="Text 61"/>
+          <p:cNvSpPr/>
+          <p:nvPr/>
+        </p:nvSpPr>
+        <p:spPr>
+          <a:xfrm>
+            <a:off x="10360152" y="3776472"/>
+            <a:ext cx="1188720" cy="256032"/>
+          </a:xfrm>
+          <a:prstGeom prst="rect">
+            <a:avLst/>
+          </a:prstGeom>
+          <a:noFill/>
+          <a:ln/>
+        </p:spPr>
+        <p:txBody>
+          <a:bodyPr wrap="square" lIns="0" tIns="0" rIns="0" bIns="0" rtlCol="0" anchor="ctr"/>
+          <a:lstStyle/>
+          <a:p>
+            <a:pPr marL="0" indent="0" algn="r">
+              <a:buNone/>
+            </a:pPr>
+            <a:r>
+              <a:rPr lang="en-US" sz="1300" b="1" dirty="0">
+                <a:solidFill>
+                  <a:srgbClr val="DD841C"/>
+                </a:solidFill>
+                <a:latin typeface="Arial" pitchFamily="34" charset="0"/>
+                <a:ea typeface="Arial" pitchFamily="34" charset="-122"/>
+                <a:cs typeface="Arial" pitchFamily="34" charset="-120"/>
+              </a:rPr>
+              <a:t>$44–100</a:t>
+            </a:r>
+            <a:endParaRPr lang="en-US" sz="1300" dirty="0"/>
+          </a:p>
+        </p:txBody>
+      </p:sp>
+      <p:sp>
+        <p:nvSpPr>
+          <p:cNvPr id="66" name="Text 62"/>
+          <p:cNvSpPr/>
+          <p:nvPr/>
+        </p:nvSpPr>
+        <p:spPr>
+          <a:xfrm>
+            <a:off x="7031736" y="4032504"/>
+            <a:ext cx="4517136" cy="201168"/>
+          </a:xfrm>
+          <a:prstGeom prst="rect">
+            <a:avLst/>
+          </a:prstGeom>
+          <a:noFill/>
+          <a:ln/>
+        </p:spPr>
+        <p:txBody>
+          <a:bodyPr wrap="square" lIns="0" tIns="0" rIns="0" bIns="0" rtlCol="0" anchor="ctr"/>
+          <a:lstStyle/>
+          <a:p>
+            <a:pPr marL="0" indent="0">
+              <a:buNone/>
+            </a:pPr>
+            <a:r>
+              <a:rPr lang="en-US" sz="1050" dirty="0">
+                <a:solidFill>
+                  <a:srgbClr val="5C6B76"/>
+                </a:solidFill>
+                <a:latin typeface="Calibri" pitchFamily="34" charset="0"/>
+                <a:ea typeface="Calibri" pitchFamily="34" charset="-122"/>
+                <a:cs typeface="Calibri" pitchFamily="34" charset="-120"/>
+              </a:rPr>
+              <a:t>Leggings, cargo &amp; fleece — broadest</a:t>
+            </a:r>
+            <a:endParaRPr lang="en-US" sz="1050" dirty="0"/>
+          </a:p>
+        </p:txBody>
+      </p:sp>
+      <p:sp>
+        <p:nvSpPr>
+          <p:cNvPr id="67" name="Text 63"/>
+          <p:cNvSpPr/>
+          <p:nvPr/>
+        </p:nvSpPr>
+        <p:spPr>
+          <a:xfrm>
+            <a:off x="7031736" y="4224528"/>
+            <a:ext cx="4517136" cy="182880"/>
+          </a:xfrm>
+          <a:prstGeom prst="rect">
+            <a:avLst/>
+          </a:prstGeom>
+          <a:noFill/>
+          <a:ln/>
+        </p:spPr>
+        <p:txBody>
+          <a:bodyPr wrap="square" lIns="0" tIns="0" rIns="0" bIns="0" rtlCol="0" anchor="ctr"/>
+          <a:lstStyle/>
+          <a:p>
+            <a:pPr marL="0" indent="0">
+              <a:buNone/>
+            </a:pPr>
+            <a:r>
+              <a:rPr lang="en-US" sz="850" b="1" kern="0" spc="50" dirty="0">
+                <a:solidFill>
+                  <a:srgbClr val="9A6212"/>
+                </a:solidFill>
+                <a:latin typeface="Arial" pitchFamily="34" charset="0"/>
+                <a:ea typeface="Arial" pitchFamily="34" charset="-122"/>
+                <a:cs typeface="Arial" pitchFamily="34" charset="-120"/>
+              </a:rPr>
+              <a:t>TOP SELLER leggings</a:t>
+            </a:r>
+            <a:endParaRPr lang="en-US" sz="850" dirty="0"/>
+          </a:p>
+        </p:txBody>
+      </p:sp>
+      <p:sp>
+        <p:nvSpPr>
+          <p:cNvPr id="68" name="Shape 64"/>
+          <p:cNvSpPr/>
+          <p:nvPr/>
+        </p:nvSpPr>
+        <p:spPr>
+          <a:xfrm>
+            <a:off x="6245352" y="4544568"/>
+            <a:ext cx="5486400" cy="758952"/>
+          </a:xfrm>
+          <a:prstGeom prst="roundRect">
+            <a:avLst>
+              <a:gd name="adj" fmla="val 7229"/>
+            </a:avLst>
+          </a:prstGeom>
+          <a:solidFill>
+            <a:srgbClr val="F3F5F6"/>
+          </a:solidFill>
+          <a:ln/>
+          <a:effectLst>
+            <a:outerShdw blurRad="88900" dist="25400" dir="5400000" algn="bl" rotWithShape="0">
+              <a:srgbClr val="000000">
+                <a:alpha val="13000"/>
+              </a:srgbClr>
+            </a:outerShdw>
+          </a:effectLst>
+        </p:spPr>
+      </p:sp>
+      <p:sp>
+        <p:nvSpPr>
+          <p:cNvPr id="69" name="Shape 65"/>
+          <p:cNvSpPr/>
+          <p:nvPr/>
+        </p:nvSpPr>
+        <p:spPr>
+          <a:xfrm>
+            <a:off x="6409944" y="4700016"/>
+            <a:ext cx="457200" cy="457200"/>
+          </a:xfrm>
+          <a:prstGeom prst="ellipse">
+            <a:avLst/>
+          </a:prstGeom>
+          <a:solidFill>
+            <a:srgbClr val="2B3640"/>
+          </a:solidFill>
+          <a:ln/>
+        </p:spPr>
+      </p:sp>
+      <p:sp>
+        <p:nvSpPr>
+          <p:cNvPr id="70" name="Text 66"/>
+          <p:cNvSpPr/>
+          <p:nvPr/>
+        </p:nvSpPr>
+        <p:spPr>
+          <a:xfrm>
+            <a:off x="6409944" y="4700016"/>
+            <a:ext cx="457200" cy="457200"/>
+          </a:xfrm>
+          <a:prstGeom prst="rect">
+            <a:avLst/>
+          </a:prstGeom>
+          <a:noFill/>
+          <a:ln/>
+        </p:spPr>
+        <p:txBody>
+          <a:bodyPr wrap="square" lIns="0" tIns="0" rIns="0" bIns="0" rtlCol="0" anchor="ctr"/>
+          <a:lstStyle/>
+          <a:p>
+            <a:pPr marL="0" indent="0" algn="ctr">
+              <a:buNone/>
+            </a:pPr>
+            <a:r>
+              <a:rPr lang="en-US" sz="1800" b="1" dirty="0">
+                <a:solidFill>
+                  <a:srgbClr val="DD841C"/>
+                </a:solidFill>
+                <a:latin typeface="Arial" pitchFamily="34" charset="0"/>
+                <a:ea typeface="Arial" pitchFamily="34" charset="-122"/>
+                <a:cs typeface="Arial" pitchFamily="34" charset="-120"/>
+              </a:rPr>
+              <a:t>4</a:t>
+            </a:r>
+            <a:endParaRPr lang="en-US" sz="1800" dirty="0"/>
+          </a:p>
+        </p:txBody>
+      </p:sp>
+      <p:sp>
+        <p:nvSpPr>
+          <p:cNvPr id="71" name="Text 67"/>
+          <p:cNvSpPr/>
+          <p:nvPr/>
+        </p:nvSpPr>
+        <p:spPr>
+          <a:xfrm>
+            <a:off x="7031736" y="4626864"/>
+            <a:ext cx="3328416" cy="256032"/>
+          </a:xfrm>
+          <a:prstGeom prst="rect">
+            <a:avLst/>
+          </a:prstGeom>
+          <a:noFill/>
+          <a:ln/>
+        </p:spPr>
+        <p:txBody>
+          <a:bodyPr wrap="square" lIns="0" tIns="0" rIns="0" bIns="0" rtlCol="0" anchor="ctr"/>
+          <a:lstStyle/>
+          <a:p>
+            <a:pPr marL="0" indent="0">
+              <a:buNone/>
+            </a:pPr>
+            <a:r>
+              <a:rPr lang="en-US" sz="1400" b="1" dirty="0">
+                <a:solidFill>
+                  <a:srgbClr val="20292F"/>
+                </a:solidFill>
+                <a:latin typeface="Arial" pitchFamily="34" charset="0"/>
+                <a:ea typeface="Arial" pitchFamily="34" charset="-122"/>
+                <a:cs typeface="Arial" pitchFamily="34" charset="-120"/>
+              </a:rPr>
+              <a:t>e.s.concrete light</a:t>
+            </a:r>
+            <a:endParaRPr lang="en-US" sz="1400" dirty="0"/>
+          </a:p>
+        </p:txBody>
+      </p:sp>
+      <p:sp>
+        <p:nvSpPr>
+          <p:cNvPr id="72" name="Text 68"/>
+          <p:cNvSpPr/>
+          <p:nvPr/>
+        </p:nvSpPr>
+        <p:spPr>
+          <a:xfrm>
+            <a:off x="10360152" y="4626864"/>
+            <a:ext cx="1188720" cy="256032"/>
+          </a:xfrm>
+          <a:prstGeom prst="rect">
+            <a:avLst/>
+          </a:prstGeom>
+          <a:noFill/>
+          <a:ln/>
+        </p:spPr>
+        <p:txBody>
+          <a:bodyPr wrap="square" lIns="0" tIns="0" rIns="0" bIns="0" rtlCol="0" anchor="ctr"/>
+          <a:lstStyle/>
+          <a:p>
+            <a:pPr marL="0" indent="0" algn="r">
+              <a:buNone/>
+            </a:pPr>
+            <a:r>
+              <a:rPr lang="en-US" sz="1300" b="1" dirty="0">
+                <a:solidFill>
+                  <a:srgbClr val="DD841C"/>
+                </a:solidFill>
+                <a:latin typeface="Arial" pitchFamily="34" charset="0"/>
+                <a:ea typeface="Arial" pitchFamily="34" charset="-122"/>
+                <a:cs typeface="Arial" pitchFamily="34" charset="-120"/>
+              </a:rPr>
+              <a:t>$99</a:t>
+            </a:r>
+            <a:endParaRPr lang="en-US" sz="1300" dirty="0"/>
+          </a:p>
+        </p:txBody>
+      </p:sp>
+      <p:sp>
+        <p:nvSpPr>
+          <p:cNvPr id="73" name="Text 69"/>
+          <p:cNvSpPr/>
+          <p:nvPr/>
+        </p:nvSpPr>
+        <p:spPr>
+          <a:xfrm>
+            <a:off x="7031736" y="4882896"/>
+            <a:ext cx="4517136" cy="201168"/>
+          </a:xfrm>
+          <a:prstGeom prst="rect">
+            <a:avLst/>
+          </a:prstGeom>
+          <a:noFill/>
+          <a:ln/>
+        </p:spPr>
+        <p:txBody>
+          <a:bodyPr wrap="square" lIns="0" tIns="0" rIns="0" bIns="0" rtlCol="0" anchor="ctr"/>
+          <a:lstStyle/>
+          <a:p>
+            <a:pPr marL="0" indent="0">
+              <a:buNone/>
+            </a:pPr>
+            <a:r>
+              <a:rPr lang="en-US" sz="1050" dirty="0">
+                <a:solidFill>
+                  <a:srgbClr val="5C6B76"/>
+                </a:solidFill>
+                <a:latin typeface="Calibri" pitchFamily="34" charset="0"/>
+                <a:ea typeface="Calibri" pitchFamily="34" charset="-122"/>
+                <a:cs typeface="Calibri" pitchFamily="34" charset="-120"/>
+              </a:rPr>
+              <a:t>Ultra-light work pants</a:t>
+            </a:r>
+            <a:endParaRPr lang="en-US" sz="1050" dirty="0"/>
+          </a:p>
+        </p:txBody>
+      </p:sp>
+      <p:sp>
+        <p:nvSpPr>
+          <p:cNvPr id="74" name="Text 70"/>
+          <p:cNvSpPr/>
+          <p:nvPr/>
+        </p:nvSpPr>
+        <p:spPr>
+          <a:xfrm>
+            <a:off x="7031736" y="5074920"/>
+            <a:ext cx="4517136" cy="182880"/>
+          </a:xfrm>
+          <a:prstGeom prst="rect">
+            <a:avLst/>
+          </a:prstGeom>
+          <a:noFill/>
+          <a:ln/>
+        </p:spPr>
+        <p:txBody>
+          <a:bodyPr wrap="square" lIns="0" tIns="0" rIns="0" bIns="0" rtlCol="0" anchor="ctr"/>
+          <a:lstStyle/>
+          <a:p>
+            <a:pPr marL="0" indent="0">
+              <a:buNone/>
+            </a:pPr>
+            <a:r>
+              <a:rPr lang="en-US" sz="850" b="1" kern="0" spc="50" dirty="0">
+                <a:solidFill>
+                  <a:srgbClr val="9A6212"/>
+                </a:solidFill>
+                <a:latin typeface="Arial" pitchFamily="34" charset="0"/>
+                <a:ea typeface="Arial" pitchFamily="34" charset="-122"/>
+                <a:cs typeface="Arial" pitchFamily="34" charset="-120"/>
+              </a:rPr>
+              <a:t>#2 BEST-SELLER slot</a:t>
+            </a:r>
+            <a:endParaRPr lang="en-US" sz="850" dirty="0"/>
+          </a:p>
+        </p:txBody>
+      </p:sp>
+      <p:sp>
+        <p:nvSpPr>
+          <p:cNvPr id="75" name="Shape 71"/>
+          <p:cNvSpPr/>
+          <p:nvPr/>
+        </p:nvSpPr>
+        <p:spPr>
+          <a:xfrm>
+            <a:off x="6245352" y="5394960"/>
+            <a:ext cx="5486400" cy="758952"/>
+          </a:xfrm>
+          <a:prstGeom prst="roundRect">
+            <a:avLst>
+              <a:gd name="adj" fmla="val 7229"/>
+            </a:avLst>
+          </a:prstGeom>
+          <a:solidFill>
+            <a:srgbClr val="F3F5F6"/>
+          </a:solidFill>
+          <a:ln/>
+          <a:effectLst>
+            <a:outerShdw blurRad="88900" dist="25400" dir="5400000" algn="bl" rotWithShape="0">
+              <a:srgbClr val="000000">
+                <a:alpha val="13000"/>
+              </a:srgbClr>
+            </a:outerShdw>
+          </a:effectLst>
+        </p:spPr>
+      </p:sp>
+      <p:sp>
+        <p:nvSpPr>
+          <p:cNvPr id="76" name="Shape 72"/>
+          <p:cNvSpPr/>
+          <p:nvPr/>
+        </p:nvSpPr>
+        <p:spPr>
+          <a:xfrm>
+            <a:off x="6409944" y="5550408"/>
+            <a:ext cx="457200" cy="457200"/>
+          </a:xfrm>
+          <a:prstGeom prst="ellipse">
+            <a:avLst/>
+          </a:prstGeom>
+          <a:solidFill>
+            <a:srgbClr val="2B3640"/>
+          </a:solidFill>
+          <a:ln/>
+        </p:spPr>
+      </p:sp>
+      <p:sp>
+        <p:nvSpPr>
+          <p:cNvPr id="77" name="Text 73"/>
+          <p:cNvSpPr/>
+          <p:nvPr/>
+        </p:nvSpPr>
+        <p:spPr>
+          <a:xfrm>
+            <a:off x="6409944" y="5550408"/>
+            <a:ext cx="457200" cy="457200"/>
+          </a:xfrm>
+          <a:prstGeom prst="rect">
+            <a:avLst/>
+          </a:prstGeom>
+          <a:noFill/>
+          <a:ln/>
+        </p:spPr>
+        <p:txBody>
+          <a:bodyPr wrap="square" lIns="0" tIns="0" rIns="0" bIns="0" rtlCol="0" anchor="ctr"/>
+          <a:lstStyle/>
+          <a:p>
+            <a:pPr marL="0" indent="0" algn="ctr">
+              <a:buNone/>
+            </a:pPr>
+            <a:r>
+              <a:rPr lang="en-US" sz="1800" b="1" dirty="0">
+                <a:solidFill>
+                  <a:srgbClr val="DD841C"/>
+                </a:solidFill>
+                <a:latin typeface="Arial" pitchFamily="34" charset="0"/>
+                <a:ea typeface="Arial" pitchFamily="34" charset="-122"/>
+                <a:cs typeface="Arial" pitchFamily="34" charset="-120"/>
+              </a:rPr>
+              <a:t>5</a:t>
+            </a:r>
+            <a:endParaRPr lang="en-US" sz="1800" dirty="0"/>
+          </a:p>
+        </p:txBody>
+      </p:sp>
+      <p:sp>
+        <p:nvSpPr>
+          <p:cNvPr id="78" name="Text 74"/>
+          <p:cNvSpPr/>
+          <p:nvPr/>
+        </p:nvSpPr>
+        <p:spPr>
+          <a:xfrm>
+            <a:off x="7031736" y="5477256"/>
+            <a:ext cx="3328416" cy="256032"/>
+          </a:xfrm>
+          <a:prstGeom prst="rect">
+            <a:avLst/>
+          </a:prstGeom>
+          <a:noFill/>
+          <a:ln/>
+        </p:spPr>
+        <p:txBody>
+          <a:bodyPr wrap="square" lIns="0" tIns="0" rIns="0" bIns="0" rtlCol="0" anchor="ctr"/>
+          <a:lstStyle/>
+          <a:p>
+            <a:pPr marL="0" indent="0">
+              <a:buNone/>
+            </a:pPr>
+            <a:r>
+              <a:rPr lang="en-US" sz="1400" b="1" dirty="0">
+                <a:solidFill>
+                  <a:srgbClr val="20292F"/>
+                </a:solidFill>
+                <a:latin typeface="Arial" pitchFamily="34" charset="0"/>
+                <a:ea typeface="Arial" pitchFamily="34" charset="-122"/>
+                <a:cs typeface="Arial" pitchFamily="34" charset="-120"/>
+              </a:rPr>
+              <a:t>e.s.trail</a:t>
+            </a:r>
+            <a:endParaRPr lang="en-US" sz="1400" dirty="0"/>
+          </a:p>
+        </p:txBody>
+      </p:sp>
+      <p:sp>
+        <p:nvSpPr>
+          <p:cNvPr id="79" name="Text 75"/>
+          <p:cNvSpPr/>
+          <p:nvPr/>
+        </p:nvSpPr>
+        <p:spPr>
+          <a:xfrm>
+            <a:off x="10360152" y="5477256"/>
+            <a:ext cx="1188720" cy="256032"/>
+          </a:xfrm>
+          <a:prstGeom prst="rect">
+            <a:avLst/>
+          </a:prstGeom>
+          <a:noFill/>
+          <a:ln/>
+        </p:spPr>
+        <p:txBody>
+          <a:bodyPr wrap="square" lIns="0" tIns="0" rIns="0" bIns="0" rtlCol="0" anchor="ctr"/>
+          <a:lstStyle/>
+          <a:p>
+            <a:pPr marL="0" indent="0" algn="r">
+              <a:buNone/>
+            </a:pPr>
+            <a:r>
+              <a:rPr lang="en-US" sz="1300" b="1" dirty="0">
+                <a:solidFill>
+                  <a:srgbClr val="DD841C"/>
+                </a:solidFill>
+                <a:latin typeface="Arial" pitchFamily="34" charset="0"/>
+                <a:ea typeface="Arial" pitchFamily="34" charset="-122"/>
+                <a:cs typeface="Arial" pitchFamily="34" charset="-120"/>
+              </a:rPr>
+              <a:t>$79–139</a:t>
+            </a:r>
+            <a:endParaRPr lang="en-US" sz="1300" dirty="0"/>
+          </a:p>
+        </p:txBody>
+      </p:sp>
+      <p:sp>
+        <p:nvSpPr>
+          <p:cNvPr id="80" name="Text 76"/>
+          <p:cNvSpPr/>
+          <p:nvPr/>
+        </p:nvSpPr>
+        <p:spPr>
+          <a:xfrm>
+            <a:off x="7031736" y="5733288"/>
+            <a:ext cx="4517136" cy="201168"/>
+          </a:xfrm>
+          <a:prstGeom prst="rect">
+            <a:avLst/>
+          </a:prstGeom>
+          <a:noFill/>
+          <a:ln/>
+        </p:spPr>
+        <p:txBody>
+          <a:bodyPr wrap="square" lIns="0" tIns="0" rIns="0" bIns="0" rtlCol="0" anchor="ctr"/>
+          <a:lstStyle/>
+          <a:p>
+            <a:pPr marL="0" indent="0">
+              <a:buNone/>
+            </a:pPr>
+            <a:r>
+              <a:rPr lang="en-US" sz="1050" dirty="0">
+                <a:solidFill>
+                  <a:srgbClr val="5C6B76"/>
+                </a:solidFill>
+                <a:latin typeface="Calibri" pitchFamily="34" charset="0"/>
+                <a:ea typeface="Calibri" pitchFamily="34" charset="-122"/>
+                <a:cs typeface="Calibri" pitchFamily="34" charset="-120"/>
+              </a:rPr>
+              <a:t>Athletic leggings &amp; hybrid jackets</a:t>
+            </a:r>
+            <a:endParaRPr lang="en-US" sz="1050" dirty="0"/>
+          </a:p>
+        </p:txBody>
+      </p:sp>
+      <p:sp>
+        <p:nvSpPr>
+          <p:cNvPr id="81" name="Text 77"/>
+          <p:cNvSpPr/>
+          <p:nvPr/>
+        </p:nvSpPr>
+        <p:spPr>
+          <a:xfrm>
+            <a:off x="7031736" y="5925312"/>
+            <a:ext cx="4517136" cy="182880"/>
+          </a:xfrm>
+          <a:prstGeom prst="rect">
+            <a:avLst/>
+          </a:prstGeom>
+          <a:noFill/>
+          <a:ln/>
+        </p:spPr>
+        <p:txBody>
+          <a:bodyPr wrap="square" lIns="0" tIns="0" rIns="0" bIns="0" rtlCol="0" anchor="ctr"/>
+          <a:lstStyle/>
+          <a:p>
+            <a:pPr marL="0" indent="0">
+              <a:buNone/>
+            </a:pPr>
+            <a:r>
+              <a:rPr lang="en-US" sz="850" b="1" kern="0" spc="50" dirty="0">
+                <a:solidFill>
+                  <a:srgbClr val="9A6212"/>
+                </a:solidFill>
+                <a:latin typeface="Arial" pitchFamily="34" charset="0"/>
+                <a:ea typeface="Arial" pitchFamily="34" charset="-122"/>
+                <a:cs typeface="Arial" pitchFamily="34" charset="-120"/>
+              </a:rPr>
+              <a:t>ACTIVEWEAR crossover</a:t>
+            </a:r>
+            <a:endParaRPr lang="en-US" sz="850" dirty="0"/>
+          </a:p>
+        </p:txBody>
+      </p:sp>
+      <p:sp>
+        <p:nvSpPr>
+          <p:cNvPr id="82" name="Shape 78"/>
+          <p:cNvSpPr/>
+          <p:nvPr/>
+        </p:nvSpPr>
+        <p:spPr>
+          <a:xfrm>
+            <a:off x="0" y="6400800"/>
+            <a:ext cx="12188952" cy="457200"/>
+          </a:xfrm>
+          <a:prstGeom prst="rect">
+            <a:avLst/>
+          </a:prstGeom>
+          <a:solidFill>
+            <a:srgbClr val="2B3640"/>
+          </a:solidFill>
+          <a:ln/>
+        </p:spPr>
+      </p:sp>
+      <p:sp>
+        <p:nvSpPr>
+          <p:cNvPr id="83" name="Text 79"/>
+          <p:cNvSpPr/>
+          <p:nvPr/>
+        </p:nvSpPr>
+        <p:spPr>
+          <a:xfrm>
+            <a:off x="457200" y="6400800"/>
+            <a:ext cx="11247120" cy="457200"/>
+          </a:xfrm>
+          <a:prstGeom prst="rect">
+            <a:avLst/>
+          </a:prstGeom>
+          <a:noFill/>
+          <a:ln/>
+        </p:spPr>
+        <p:txBody>
+          <a:bodyPr wrap="square" lIns="0" tIns="0" rIns="0" bIns="0" rtlCol="0" anchor="ctr"/>
+          <a:lstStyle/>
+          <a:p>
+            <a:pPr marL="0" indent="0">
+              <a:buNone/>
+            </a:pPr>
+            <a:r>
+              <a:rPr lang="en-US" sz="950" i="1" dirty="0">
+                <a:solidFill>
+                  <a:srgbClr val="9AA6AD"/>
+                </a:solidFill>
+                <a:latin typeface="Calibri" pitchFamily="34" charset="0"/>
+                <a:ea typeface="Calibri" pitchFamily="34" charset="-122"/>
+                <a:cs typeface="Calibri" pitchFamily="34" charset="-120"/>
+              </a:rPr>
+              <a:t>Source: us.strauss.com — Men’s &amp; Women’s collection pages, product pages and homepage signals.</a:t>
+            </a:r>
+            <a:endParaRPr lang="en-US" sz="950" dirty="0"/>
+          </a:p>
+        </p:txBody>
+      </p:sp>
+    </p:spTree>
+  </p:cSld>
+  <p:clrMapOvr>
+    <a:masterClrMapping/>
+  </p:clrMapOvr>
+</p:sld>
+</file>
+
+<file path=ppt/slides/slide2.xml><?xml version="1.0" encoding="utf-8"?>
+<p:sld xmlns:a="http://schemas.openxmlformats.org/drawingml/2006/main" xmlns:r="http://schemas.openxmlformats.org/officeDocument/2006/relationships" xmlns:p="http://schemas.openxmlformats.org/presentationml/2006/main">
   <p:cSld name="Slide 1">
     <p:bg>
       <p:bgPr>
         <a:solidFill>
           <a:srgbClr val="FFFFFF"/>
         </a:solidFill>
+        <a:effectLst/>
       </p:bgPr>
     </p:bg>
     <p:spTree>
@@ -1095,14 +3782,14 @@
       </p:sp>
       <p:pic>
         <p:nvPicPr>
-          <p:cNvPr id="4" name="Image 0" descr="preencoded.png">    </p:cNvPr>
+          <p:cNvPr id="4" name="Image 0" descr="preencoded.png"/>
           <p:cNvPicPr>
             <a:picLocks noChangeAspect="1"/>
           </p:cNvPicPr>
           <p:nvPr/>
         </p:nvPicPr>
         <p:blipFill>
-          <a:blip r:embed="rId1"/>
+          <a:blip r:embed="rId3"/>
           <a:stretch>
             <a:fillRect/>
           </a:stretch>
@@ -1138,11 +3825,11 @@
           <a:bodyPr wrap="square" lIns="0" tIns="0" rIns="0" bIns="0" rtlCol="0" anchor="ctr"/>
           <a:lstStyle/>
           <a:p>
-            <a:pPr indent="0" marL="0">
-              <a:buNone/>
-            </a:pPr>
-            <a:r>
-              <a:rPr lang="en-US" sz="1000" b="1" spc="200" kern="0" dirty="0">
+            <a:pPr marL="0" indent="0">
+              <a:buNone/>
+            </a:pPr>
+            <a:r>
+              <a:rPr lang="en-US" sz="1000" b="1" kern="0" spc="200" dirty="0">
                 <a:solidFill>
                   <a:srgbClr val="DD841C"/>
                 </a:solidFill>
@@ -1177,7 +3864,7 @@
           <a:bodyPr wrap="square" lIns="0" tIns="0" rIns="0" bIns="0" rtlCol="0" anchor="ctr"/>
           <a:lstStyle/>
           <a:p>
-            <a:pPr indent="0" marL="0">
+            <a:pPr marL="0" indent="0">
               <a:buNone/>
             </a:pPr>
             <a:r>
@@ -1216,7 +3903,7 @@
           <a:bodyPr wrap="square" lIns="0" tIns="0" rIns="0" bIns="0" rtlCol="0" anchor="ctr"/>
           <a:lstStyle/>
           <a:p>
-            <a:pPr indent="0" marL="0">
+            <a:pPr marL="0" indent="0">
               <a:buNone/>
             </a:pPr>
             <a:r>
@@ -1236,15 +3923,15 @@
       </p:sp>
       <p:pic>
         <p:nvPicPr>
-          <p:cNvPr id="8" name="Image 1" descr="preencoded.png">    </p:cNvPr>
+          <p:cNvPr id="8" name="Image 1" descr="preencoded.png"/>
           <p:cNvPicPr>
             <a:picLocks noChangeAspect="1"/>
           </p:cNvPicPr>
           <p:nvPr/>
         </p:nvPicPr>
         <p:blipFill>
-          <a:blip r:embed="rId2"/>
-          <a:srcRect l="0" r="0" t="0" b="0"/>
+          <a:blip r:embed="rId4"/>
+          <a:srcRect/>
           <a:stretch/>
         </p:blipFill>
         <p:spPr>
@@ -1300,11 +3987,11 @@
           <a:bodyPr wrap="square" lIns="0" tIns="0" rIns="0" bIns="0" rtlCol="0" anchor="ctr"/>
           <a:lstStyle/>
           <a:p>
-            <a:pPr indent="0" marL="0">
-              <a:buNone/>
-            </a:pPr>
-            <a:r>
-              <a:rPr lang="en-US" sz="950" b="1" spc="30" kern="0" dirty="0">
+            <a:pPr marL="0" indent="0">
+              <a:buNone/>
+            </a:pPr>
+            <a:r>
+              <a:rPr lang="en-US" sz="950" b="1" kern="0" spc="30" dirty="0">
                 <a:solidFill>
                   <a:srgbClr val="5C6B76"/>
                 </a:solidFill>
@@ -1339,7 +4026,7 @@
           <a:bodyPr wrap="square" lIns="0" tIns="0" rIns="0" bIns="0" rtlCol="0" anchor="ctr"/>
           <a:lstStyle/>
           <a:p>
-            <a:pPr indent="0" marL="0">
+            <a:pPr marL="0" indent="0">
               <a:buNone/>
             </a:pPr>
             <a:r>
@@ -1378,7 +4065,7 @@
           <a:bodyPr wrap="square" lIns="0" tIns="0" rIns="0" bIns="0" rtlCol="0" anchor="ctr"/>
           <a:lstStyle/>
           <a:p>
-            <a:pPr indent="0" marL="0">
+            <a:pPr marL="0" indent="0">
               <a:buNone/>
             </a:pPr>
             <a:r>
@@ -1417,7 +4104,7 @@
           <a:bodyPr wrap="square" lIns="0" tIns="0" rIns="0" bIns="0" rtlCol="0" anchor="ctr"/>
           <a:lstStyle/>
           <a:p>
-            <a:pPr indent="0" marL="0">
+            <a:pPr marL="0" indent="0">
               <a:buNone/>
             </a:pPr>
             <a:r>
@@ -1456,7 +4143,7 @@
           <a:bodyPr wrap="square" lIns="0" tIns="0" rIns="0" bIns="0" rtlCol="0" anchor="ctr"/>
           <a:lstStyle/>
           <a:p>
-            <a:pPr indent="0" marL="0">
+            <a:pPr marL="0" indent="0">
               <a:buNone/>
             </a:pPr>
             <a:r>
@@ -1476,15 +4163,15 @@
       </p:sp>
       <p:pic>
         <p:nvPicPr>
-          <p:cNvPr id="15" name="Image 2" descr="preencoded.png">    </p:cNvPr>
+          <p:cNvPr id="15" name="Image 2" descr="preencoded.png"/>
           <p:cNvPicPr>
             <a:picLocks noChangeAspect="1"/>
           </p:cNvPicPr>
           <p:nvPr/>
         </p:nvPicPr>
         <p:blipFill>
-          <a:blip r:embed="rId3"/>
-          <a:srcRect l="0" r="0" t="0" b="0"/>
+          <a:blip r:embed="rId5"/>
+          <a:srcRect/>
           <a:stretch/>
         </p:blipFill>
         <p:spPr>
@@ -1540,11 +4227,11 @@
           <a:bodyPr wrap="square" lIns="0" tIns="0" rIns="0" bIns="0" rtlCol="0" anchor="ctr"/>
           <a:lstStyle/>
           <a:p>
-            <a:pPr indent="0" marL="0">
-              <a:buNone/>
-            </a:pPr>
-            <a:r>
-              <a:rPr lang="en-US" sz="950" b="1" spc="30" kern="0" dirty="0">
+            <a:pPr marL="0" indent="0">
+              <a:buNone/>
+            </a:pPr>
+            <a:r>
+              <a:rPr lang="en-US" sz="950" b="1" kern="0" spc="30" dirty="0">
                 <a:solidFill>
                   <a:srgbClr val="5C6B76"/>
                 </a:solidFill>
@@ -1579,7 +4266,7 @@
           <a:bodyPr wrap="square" lIns="0" tIns="0" rIns="0" bIns="0" rtlCol="0" anchor="ctr"/>
           <a:lstStyle/>
           <a:p>
-            <a:pPr indent="0" marL="0">
+            <a:pPr marL="0" indent="0">
               <a:buNone/>
             </a:pPr>
             <a:r>
@@ -1618,7 +4305,7 @@
           <a:bodyPr wrap="square" lIns="0" tIns="0" rIns="0" bIns="0" rtlCol="0" anchor="ctr"/>
           <a:lstStyle/>
           <a:p>
-            <a:pPr indent="0" marL="0">
+            <a:pPr marL="0" indent="0">
               <a:buNone/>
             </a:pPr>
             <a:r>
@@ -1657,7 +4344,7 @@
           <a:bodyPr wrap="square" lIns="0" tIns="0" rIns="0" bIns="0" rtlCol="0" anchor="ctr"/>
           <a:lstStyle/>
           <a:p>
-            <a:pPr indent="0" marL="0">
+            <a:pPr marL="0" indent="0">
               <a:buNone/>
             </a:pPr>
             <a:r>
@@ -1696,7 +4383,7 @@
           <a:bodyPr wrap="square" lIns="0" tIns="0" rIns="0" bIns="0" rtlCol="0" anchor="ctr"/>
           <a:lstStyle/>
           <a:p>
-            <a:pPr indent="0" marL="0">
+            <a:pPr marL="0" indent="0">
               <a:buNone/>
             </a:pPr>
             <a:r>
@@ -1716,15 +4403,15 @@
       </p:sp>
       <p:pic>
         <p:nvPicPr>
-          <p:cNvPr id="22" name="Image 3" descr="preencoded.png">    </p:cNvPr>
+          <p:cNvPr id="22" name="Image 3" descr="preencoded.png"/>
           <p:cNvPicPr>
             <a:picLocks noChangeAspect="1"/>
           </p:cNvPicPr>
           <p:nvPr/>
         </p:nvPicPr>
         <p:blipFill>
-          <a:blip r:embed="rId4"/>
-          <a:srcRect l="0" r="0" t="0" b="0"/>
+          <a:blip r:embed="rId6"/>
+          <a:srcRect/>
           <a:stretch/>
         </p:blipFill>
         <p:spPr>
@@ -1780,11 +4467,11 @@
           <a:bodyPr wrap="square" lIns="0" tIns="0" rIns="0" bIns="0" rtlCol="0" anchor="ctr"/>
           <a:lstStyle/>
           <a:p>
-            <a:pPr indent="0" marL="0">
-              <a:buNone/>
-            </a:pPr>
-            <a:r>
-              <a:rPr lang="en-US" sz="950" b="1" spc="30" kern="0" dirty="0">
+            <a:pPr marL="0" indent="0">
+              <a:buNone/>
+            </a:pPr>
+            <a:r>
+              <a:rPr lang="en-US" sz="950" b="1" kern="0" spc="30" dirty="0">
                 <a:solidFill>
                   <a:srgbClr val="5C6B76"/>
                 </a:solidFill>
@@ -1819,7 +4506,7 @@
           <a:bodyPr wrap="square" lIns="0" tIns="0" rIns="0" bIns="0" rtlCol="0" anchor="ctr"/>
           <a:lstStyle/>
           <a:p>
-            <a:pPr indent="0" marL="0">
+            <a:pPr marL="0" indent="0">
               <a:buNone/>
             </a:pPr>
             <a:r>
@@ -1858,7 +4545,7 @@
           <a:bodyPr wrap="square" lIns="0" tIns="0" rIns="0" bIns="0" rtlCol="0" anchor="ctr"/>
           <a:lstStyle/>
           <a:p>
-            <a:pPr indent="0" marL="0">
+            <a:pPr marL="0" indent="0">
               <a:buNone/>
             </a:pPr>
             <a:r>
@@ -1897,7 +4584,7 @@
           <a:bodyPr wrap="square" lIns="0" tIns="0" rIns="0" bIns="0" rtlCol="0" anchor="ctr"/>
           <a:lstStyle/>
           <a:p>
-            <a:pPr indent="0" marL="0">
+            <a:pPr marL="0" indent="0">
               <a:buNone/>
             </a:pPr>
             <a:r>
@@ -1936,7 +4623,7 @@
           <a:bodyPr wrap="square" lIns="0" tIns="0" rIns="0" bIns="0" rtlCol="0" anchor="ctr"/>
           <a:lstStyle/>
           <a:p>
-            <a:pPr indent="0" marL="0">
+            <a:pPr marL="0" indent="0">
               <a:buNone/>
             </a:pPr>
             <a:r>
@@ -1997,7 +4684,7 @@
           <a:bodyPr wrap="square" lIns="0" tIns="0" rIns="0" bIns="0" rtlCol="0" anchor="ctr"/>
           <a:lstStyle/>
           <a:p>
-            <a:pPr indent="0" marL="0">
+            <a:pPr marL="0" indent="0">
               <a:buNone/>
             </a:pPr>
             <a:r>
@@ -2011,9 +4698,6 @@
               </a:rPr>
               <a:t>KEY POINT   </a:t>
             </a:r>
-            <a:pPr indent="0" marL="0">
-              <a:buNone/>
-            </a:pPr>
             <a:r>
               <a:rPr lang="en-US" sz="1100" dirty="0">
                 <a:solidFill>
@@ -2050,7 +4734,7 @@
           <a:bodyPr wrap="square" lIns="0" tIns="0" rIns="0" bIns="0" rtlCol="0" anchor="ctr"/>
           <a:lstStyle/>
           <a:p>
-            <a:pPr indent="0" marL="0">
+            <a:pPr marL="0" indent="0">
               <a:buNone/>
             </a:pPr>
             <a:r>
@@ -2076,7 +4760,7 @@
 </p:sld>
 </file>
 
-<file path=ppt/slides/slide2.xml><?xml version="1.0" encoding="utf-8"?>
+<file path=ppt/slides/slide3.xml><?xml version="1.0" encoding="utf-8"?>
 <p:sld xmlns:a="http://schemas.openxmlformats.org/drawingml/2006/main" xmlns:r="http://schemas.openxmlformats.org/officeDocument/2006/relationships" xmlns:p="http://schemas.openxmlformats.org/presentationml/2006/main">
   <p:cSld name="Slide 2">
     <p:bg>
@@ -2084,6 +4768,7 @@
         <a:solidFill>
           <a:srgbClr val="FFFFFF"/>
         </a:solidFill>
+        <a:effectLst/>
       </p:bgPr>
     </p:bg>
     <p:spTree>
@@ -2142,14 +4827,14 @@
       </p:sp>
       <p:pic>
         <p:nvPicPr>
-          <p:cNvPr id="4" name="Image 0" descr="preencoded.png">    </p:cNvPr>
+          <p:cNvPr id="4" name="Image 0" descr="preencoded.png"/>
           <p:cNvPicPr>
             <a:picLocks noChangeAspect="1"/>
           </p:cNvPicPr>
           <p:nvPr/>
         </p:nvPicPr>
         <p:blipFill>
-          <a:blip r:embed="rId1"/>
+          <a:blip r:embed="rId3"/>
           <a:stretch>
             <a:fillRect/>
           </a:stretch>
@@ -2185,11 +4870,11 @@
           <a:bodyPr wrap="square" lIns="0" tIns="0" rIns="0" bIns="0" rtlCol="0" anchor="ctr"/>
           <a:lstStyle/>
           <a:p>
-            <a:pPr indent="0" marL="0">
-              <a:buNone/>
-            </a:pPr>
-            <a:r>
-              <a:rPr lang="en-US" sz="1000" b="1" spc="200" kern="0" dirty="0">
+            <a:pPr marL="0" indent="0">
+              <a:buNone/>
+            </a:pPr>
+            <a:r>
+              <a:rPr lang="en-US" sz="1000" b="1" kern="0" spc="200" dirty="0">
                 <a:solidFill>
                   <a:srgbClr val="DD841C"/>
                 </a:solidFill>
@@ -2224,7 +4909,7 @@
           <a:bodyPr wrap="square" lIns="0" tIns="0" rIns="0" bIns="0" rtlCol="0" anchor="ctr"/>
           <a:lstStyle/>
           <a:p>
-            <a:pPr indent="0" marL="0">
+            <a:pPr marL="0" indent="0">
               <a:buNone/>
             </a:pPr>
             <a:r>
@@ -2263,7 +4948,7 @@
           <a:bodyPr wrap="square" lIns="0" tIns="0" rIns="0" bIns="0" rtlCol="0" anchor="ctr"/>
           <a:lstStyle/>
           <a:p>
-            <a:pPr indent="0" marL="0">
+            <a:pPr marL="0" indent="0">
               <a:buNone/>
             </a:pPr>
             <a:r>
@@ -2283,15 +4968,15 @@
       </p:sp>
       <p:pic>
         <p:nvPicPr>
-          <p:cNvPr id="8" name="Image 1" descr="preencoded.png">    </p:cNvPr>
+          <p:cNvPr id="8" name="Image 1" descr="preencoded.png"/>
           <p:cNvPicPr>
             <a:picLocks noChangeAspect="1"/>
           </p:cNvPicPr>
           <p:nvPr/>
         </p:nvPicPr>
         <p:blipFill>
-          <a:blip r:embed="rId2"/>
-          <a:srcRect l="0" r="0" t="0" b="0"/>
+          <a:blip r:embed="rId4"/>
+          <a:srcRect/>
           <a:stretch/>
         </p:blipFill>
         <p:spPr>
@@ -2347,11 +5032,11 @@
           <a:bodyPr wrap="square" lIns="0" tIns="0" rIns="0" bIns="0" rtlCol="0" anchor="ctr"/>
           <a:lstStyle/>
           <a:p>
-            <a:pPr indent="0" marL="0">
-              <a:buNone/>
-            </a:pPr>
-            <a:r>
-              <a:rPr lang="en-US" sz="950" b="1" spc="30" kern="0" dirty="0">
+            <a:pPr marL="0" indent="0">
+              <a:buNone/>
+            </a:pPr>
+            <a:r>
+              <a:rPr lang="en-US" sz="950" b="1" kern="0" spc="30" dirty="0">
                 <a:solidFill>
                   <a:srgbClr val="5C6B76"/>
                 </a:solidFill>
@@ -2386,7 +5071,7 @@
           <a:bodyPr wrap="square" lIns="0" tIns="0" rIns="0" bIns="0" rtlCol="0" anchor="ctr"/>
           <a:lstStyle/>
           <a:p>
-            <a:pPr indent="0" marL="0">
+            <a:pPr marL="0" indent="0">
               <a:buNone/>
             </a:pPr>
             <a:r>
@@ -2425,7 +5110,7 @@
           <a:bodyPr wrap="square" lIns="0" tIns="0" rIns="0" bIns="0" rtlCol="0" anchor="ctr"/>
           <a:lstStyle/>
           <a:p>
-            <a:pPr indent="0" marL="0">
+            <a:pPr marL="0" indent="0">
               <a:buNone/>
             </a:pPr>
             <a:r>
@@ -2464,7 +5149,7 @@
           <a:bodyPr wrap="square" lIns="0" tIns="0" rIns="0" bIns="0" rtlCol="0" anchor="ctr"/>
           <a:lstStyle/>
           <a:p>
-            <a:pPr indent="0" marL="0">
+            <a:pPr marL="0" indent="0">
               <a:buNone/>
             </a:pPr>
             <a:r>
@@ -2503,7 +5188,7 @@
           <a:bodyPr wrap="square" lIns="0" tIns="0" rIns="0" bIns="0" rtlCol="0" anchor="ctr"/>
           <a:lstStyle/>
           <a:p>
-            <a:pPr indent="0" marL="0">
+            <a:pPr marL="0" indent="0">
               <a:buNone/>
             </a:pPr>
             <a:r>
@@ -2523,15 +5208,15 @@
       </p:sp>
       <p:pic>
         <p:nvPicPr>
-          <p:cNvPr id="15" name="Image 2" descr="preencoded.png">    </p:cNvPr>
+          <p:cNvPr id="15" name="Image 2" descr="preencoded.png"/>
           <p:cNvPicPr>
             <a:picLocks noChangeAspect="1"/>
           </p:cNvPicPr>
           <p:nvPr/>
         </p:nvPicPr>
         <p:blipFill>
-          <a:blip r:embed="rId3"/>
-          <a:srcRect l="0" r="0" t="0" b="0"/>
+          <a:blip r:embed="rId5"/>
+          <a:srcRect/>
           <a:stretch/>
         </p:blipFill>
         <p:spPr>
@@ -2587,11 +5272,11 @@
           <a:bodyPr wrap="square" lIns="0" tIns="0" rIns="0" bIns="0" rtlCol="0" anchor="ctr"/>
           <a:lstStyle/>
           <a:p>
-            <a:pPr indent="0" marL="0">
-              <a:buNone/>
-            </a:pPr>
-            <a:r>
-              <a:rPr lang="en-US" sz="950" b="1" spc="30" kern="0" dirty="0">
+            <a:pPr marL="0" indent="0">
+              <a:buNone/>
+            </a:pPr>
+            <a:r>
+              <a:rPr lang="en-US" sz="950" b="1" kern="0" spc="30" dirty="0">
                 <a:solidFill>
                   <a:srgbClr val="5C6B76"/>
                 </a:solidFill>
@@ -2626,7 +5311,7 @@
           <a:bodyPr wrap="square" lIns="0" tIns="0" rIns="0" bIns="0" rtlCol="0" anchor="ctr"/>
           <a:lstStyle/>
           <a:p>
-            <a:pPr indent="0" marL="0">
+            <a:pPr marL="0" indent="0">
               <a:buNone/>
             </a:pPr>
             <a:r>
@@ -2665,7 +5350,7 @@
           <a:bodyPr wrap="square" lIns="0" tIns="0" rIns="0" bIns="0" rtlCol="0" anchor="ctr"/>
           <a:lstStyle/>
           <a:p>
-            <a:pPr indent="0" marL="0">
+            <a:pPr marL="0" indent="0">
               <a:buNone/>
             </a:pPr>
             <a:r>
@@ -2704,7 +5389,7 @@
           <a:bodyPr wrap="square" lIns="0" tIns="0" rIns="0" bIns="0" rtlCol="0" anchor="ctr"/>
           <a:lstStyle/>
           <a:p>
-            <a:pPr indent="0" marL="0">
+            <a:pPr marL="0" indent="0">
               <a:buNone/>
             </a:pPr>
             <a:r>
@@ -2743,7 +5428,7 @@
           <a:bodyPr wrap="square" lIns="0" tIns="0" rIns="0" bIns="0" rtlCol="0" anchor="ctr"/>
           <a:lstStyle/>
           <a:p>
-            <a:pPr indent="0" marL="0">
+            <a:pPr marL="0" indent="0">
               <a:buNone/>
             </a:pPr>
             <a:r>
@@ -2763,15 +5448,15 @@
       </p:sp>
       <p:pic>
         <p:nvPicPr>
-          <p:cNvPr id="22" name="Image 3" descr="preencoded.png">    </p:cNvPr>
+          <p:cNvPr id="22" name="Image 3" descr="preencoded.png"/>
           <p:cNvPicPr>
             <a:picLocks noChangeAspect="1"/>
           </p:cNvPicPr>
           <p:nvPr/>
         </p:nvPicPr>
         <p:blipFill>
-          <a:blip r:embed="rId4"/>
-          <a:srcRect l="0" r="0" t="0" b="0"/>
+          <a:blip r:embed="rId6"/>
+          <a:srcRect/>
           <a:stretch/>
         </p:blipFill>
         <p:spPr>
@@ -2827,11 +5512,11 @@
           <a:bodyPr wrap="square" lIns="0" tIns="0" rIns="0" bIns="0" rtlCol="0" anchor="ctr"/>
           <a:lstStyle/>
           <a:p>
-            <a:pPr indent="0" marL="0">
-              <a:buNone/>
-            </a:pPr>
-            <a:r>
-              <a:rPr lang="en-US" sz="950" b="1" spc="30" kern="0" dirty="0">
+            <a:pPr marL="0" indent="0">
+              <a:buNone/>
+            </a:pPr>
+            <a:r>
+              <a:rPr lang="en-US" sz="950" b="1" kern="0" spc="30" dirty="0">
                 <a:solidFill>
                   <a:srgbClr val="5C6B76"/>
                 </a:solidFill>
@@ -2866,7 +5551,7 @@
           <a:bodyPr wrap="square" lIns="0" tIns="0" rIns="0" bIns="0" rtlCol="0" anchor="ctr"/>
           <a:lstStyle/>
           <a:p>
-            <a:pPr indent="0" marL="0">
+            <a:pPr marL="0" indent="0">
               <a:buNone/>
             </a:pPr>
             <a:r>
@@ -2905,7 +5590,7 @@
           <a:bodyPr wrap="square" lIns="0" tIns="0" rIns="0" bIns="0" rtlCol="0" anchor="ctr"/>
           <a:lstStyle/>
           <a:p>
-            <a:pPr indent="0" marL="0">
+            <a:pPr marL="0" indent="0">
               <a:buNone/>
             </a:pPr>
             <a:r>
@@ -2944,7 +5629,7 @@
           <a:bodyPr wrap="square" lIns="0" tIns="0" rIns="0" bIns="0" rtlCol="0" anchor="ctr"/>
           <a:lstStyle/>
           <a:p>
-            <a:pPr indent="0" marL="0">
+            <a:pPr marL="0" indent="0">
               <a:buNone/>
             </a:pPr>
             <a:r>
@@ -2983,7 +5668,7 @@
           <a:bodyPr wrap="square" lIns="0" tIns="0" rIns="0" bIns="0" rtlCol="0" anchor="ctr"/>
           <a:lstStyle/>
           <a:p>
-            <a:pPr indent="0" marL="0">
+            <a:pPr marL="0" indent="0">
               <a:buNone/>
             </a:pPr>
             <a:r>
@@ -3044,7 +5729,7 @@
           <a:bodyPr wrap="square" lIns="0" tIns="0" rIns="0" bIns="0" rtlCol="0" anchor="ctr"/>
           <a:lstStyle/>
           <a:p>
-            <a:pPr indent="0" marL="0">
+            <a:pPr marL="0" indent="0">
               <a:buNone/>
             </a:pPr>
             <a:r>
@@ -3058,9 +5743,6 @@
               </a:rPr>
               <a:t>KEY POINT   </a:t>
             </a:r>
-            <a:pPr indent="0" marL="0">
-              <a:buNone/>
-            </a:pPr>
             <a:r>
               <a:rPr lang="en-US" sz="1100" dirty="0">
                 <a:solidFill>
@@ -3097,7 +5779,7 @@
           <a:bodyPr wrap="square" lIns="0" tIns="0" rIns="0" bIns="0" rtlCol="0" anchor="ctr"/>
           <a:lstStyle/>
           <a:p>
-            <a:pPr indent="0" marL="0">
+            <a:pPr marL="0" indent="0">
               <a:buNone/>
             </a:pPr>
             <a:r>
@@ -3123,7 +5805,7 @@
 </p:sld>
 </file>
 
-<file path=ppt/slides/slide3.xml><?xml version="1.0" encoding="utf-8"?>
+<file path=ppt/slides/slide4.xml><?xml version="1.0" encoding="utf-8"?>
 <p:sld xmlns:a="http://schemas.openxmlformats.org/drawingml/2006/main" xmlns:r="http://schemas.openxmlformats.org/officeDocument/2006/relationships" xmlns:p="http://schemas.openxmlformats.org/presentationml/2006/main">
   <p:cSld name="Slide 3">
     <p:bg>
@@ -3131,6 +5813,7 @@
         <a:solidFill>
           <a:srgbClr val="FFFFFF"/>
         </a:solidFill>
+        <a:effectLst/>
       </p:bgPr>
     </p:bg>
     <p:spTree>
@@ -3189,14 +5872,14 @@
       </p:sp>
       <p:pic>
         <p:nvPicPr>
-          <p:cNvPr id="4" name="Image 0" descr="preencoded.png">    </p:cNvPr>
+          <p:cNvPr id="4" name="Image 0" descr="preencoded.png"/>
           <p:cNvPicPr>
             <a:picLocks noChangeAspect="1"/>
           </p:cNvPicPr>
           <p:nvPr/>
         </p:nvPicPr>
         <p:blipFill>
-          <a:blip r:embed="rId1"/>
+          <a:blip r:embed="rId3"/>
           <a:stretch>
             <a:fillRect/>
           </a:stretch>
@@ -3232,11 +5915,11 @@
           <a:bodyPr wrap="square" lIns="0" tIns="0" rIns="0" bIns="0" rtlCol="0" anchor="ctr"/>
           <a:lstStyle/>
           <a:p>
-            <a:pPr indent="0" marL="0">
-              <a:buNone/>
-            </a:pPr>
-            <a:r>
-              <a:rPr lang="en-US" sz="1000" b="1" spc="200" kern="0" dirty="0">
+            <a:pPr marL="0" indent="0">
+              <a:buNone/>
+            </a:pPr>
+            <a:r>
+              <a:rPr lang="en-US" sz="1000" b="1" kern="0" spc="200" dirty="0">
                 <a:solidFill>
                   <a:srgbClr val="DD841C"/>
                 </a:solidFill>
@@ -3271,7 +5954,7 @@
           <a:bodyPr wrap="square" lIns="0" tIns="0" rIns="0" bIns="0" rtlCol="0" anchor="ctr"/>
           <a:lstStyle/>
           <a:p>
-            <a:pPr indent="0" marL="0">
+            <a:pPr marL="0" indent="0">
               <a:buNone/>
             </a:pPr>
             <a:r>
@@ -3310,7 +5993,7 @@
           <a:bodyPr wrap="square" lIns="0" tIns="0" rIns="0" bIns="0" rtlCol="0" anchor="ctr"/>
           <a:lstStyle/>
           <a:p>
-            <a:pPr indent="0" marL="0">
+            <a:pPr marL="0" indent="0">
               <a:buNone/>
             </a:pPr>
             <a:r>
@@ -3330,15 +6013,15 @@
       </p:sp>
       <p:pic>
         <p:nvPicPr>
-          <p:cNvPr id="8" name="Image 1" descr="preencoded.png">    </p:cNvPr>
+          <p:cNvPr id="8" name="Image 1" descr="preencoded.png"/>
           <p:cNvPicPr>
             <a:picLocks noChangeAspect="1"/>
           </p:cNvPicPr>
           <p:nvPr/>
         </p:nvPicPr>
         <p:blipFill>
-          <a:blip r:embed="rId2"/>
-          <a:srcRect l="0" r="0" t="0" b="0"/>
+          <a:blip r:embed="rId4"/>
+          <a:srcRect/>
           <a:stretch/>
         </p:blipFill>
         <p:spPr>
@@ -3394,11 +6077,11 @@
           <a:bodyPr wrap="square" lIns="0" tIns="0" rIns="0" bIns="0" rtlCol="0" anchor="ctr"/>
           <a:lstStyle/>
           <a:p>
-            <a:pPr indent="0" marL="0">
-              <a:buNone/>
-            </a:pPr>
-            <a:r>
-              <a:rPr lang="en-US" sz="950" b="1" spc="30" kern="0" dirty="0">
+            <a:pPr marL="0" indent="0">
+              <a:buNone/>
+            </a:pPr>
+            <a:r>
+              <a:rPr lang="en-US" sz="950" b="1" kern="0" spc="30" dirty="0">
                 <a:solidFill>
                   <a:srgbClr val="5C6B76"/>
                 </a:solidFill>
@@ -3433,7 +6116,7 @@
           <a:bodyPr wrap="square" lIns="0" tIns="0" rIns="0" bIns="0" rtlCol="0" anchor="ctr"/>
           <a:lstStyle/>
           <a:p>
-            <a:pPr indent="0" marL="0">
+            <a:pPr marL="0" indent="0">
               <a:buNone/>
             </a:pPr>
             <a:r>
@@ -3472,7 +6155,7 @@
           <a:bodyPr wrap="square" lIns="0" tIns="0" rIns="0" bIns="0" rtlCol="0" anchor="ctr"/>
           <a:lstStyle/>
           <a:p>
-            <a:pPr indent="0" marL="0">
+            <a:pPr marL="0" indent="0">
               <a:buNone/>
             </a:pPr>
             <a:r>
@@ -3511,7 +6194,7 @@
           <a:bodyPr wrap="square" lIns="0" tIns="0" rIns="0" bIns="0" rtlCol="0" anchor="ctr"/>
           <a:lstStyle/>
           <a:p>
-            <a:pPr indent="0" marL="0">
+            <a:pPr marL="0" indent="0">
               <a:buNone/>
             </a:pPr>
             <a:r>
@@ -3550,7 +6233,7 @@
           <a:bodyPr wrap="square" lIns="0" tIns="0" rIns="0" bIns="0" rtlCol="0" anchor="ctr"/>
           <a:lstStyle/>
           <a:p>
-            <a:pPr indent="0" marL="0">
+            <a:pPr marL="0" indent="0">
               <a:buNone/>
             </a:pPr>
             <a:r>
@@ -3570,15 +6253,15 @@
       </p:sp>
       <p:pic>
         <p:nvPicPr>
-          <p:cNvPr id="15" name="Image 2" descr="preencoded.png">    </p:cNvPr>
+          <p:cNvPr id="15" name="Image 2" descr="preencoded.png"/>
           <p:cNvPicPr>
             <a:picLocks noChangeAspect="1"/>
           </p:cNvPicPr>
           <p:nvPr/>
         </p:nvPicPr>
         <p:blipFill>
-          <a:blip r:embed="rId3"/>
-          <a:srcRect l="0" r="0" t="0" b="0"/>
+          <a:blip r:embed="rId5"/>
+          <a:srcRect/>
           <a:stretch/>
         </p:blipFill>
         <p:spPr>
@@ -3634,11 +6317,11 @@
           <a:bodyPr wrap="square" lIns="0" tIns="0" rIns="0" bIns="0" rtlCol="0" anchor="ctr"/>
           <a:lstStyle/>
           <a:p>
-            <a:pPr indent="0" marL="0">
-              <a:buNone/>
-            </a:pPr>
-            <a:r>
-              <a:rPr lang="en-US" sz="950" b="1" spc="30" kern="0" dirty="0">
+            <a:pPr marL="0" indent="0">
+              <a:buNone/>
+            </a:pPr>
+            <a:r>
+              <a:rPr lang="en-US" sz="950" b="1" kern="0" spc="30" dirty="0">
                 <a:solidFill>
                   <a:srgbClr val="5C6B76"/>
                 </a:solidFill>
@@ -3673,7 +6356,7 @@
           <a:bodyPr wrap="square" lIns="0" tIns="0" rIns="0" bIns="0" rtlCol="0" anchor="ctr"/>
           <a:lstStyle/>
           <a:p>
-            <a:pPr indent="0" marL="0">
+            <a:pPr marL="0" indent="0">
               <a:buNone/>
             </a:pPr>
             <a:r>
@@ -3712,7 +6395,7 @@
           <a:bodyPr wrap="square" lIns="0" tIns="0" rIns="0" bIns="0" rtlCol="0" anchor="ctr"/>
           <a:lstStyle/>
           <a:p>
-            <a:pPr indent="0" marL="0">
+            <a:pPr marL="0" indent="0">
               <a:buNone/>
             </a:pPr>
             <a:r>
@@ -3751,7 +6434,7 @@
           <a:bodyPr wrap="square" lIns="0" tIns="0" rIns="0" bIns="0" rtlCol="0" anchor="ctr"/>
           <a:lstStyle/>
           <a:p>
-            <a:pPr indent="0" marL="0">
+            <a:pPr marL="0" indent="0">
               <a:buNone/>
             </a:pPr>
             <a:r>
@@ -3790,7 +6473,7 @@
           <a:bodyPr wrap="square" lIns="0" tIns="0" rIns="0" bIns="0" rtlCol="0" anchor="ctr"/>
           <a:lstStyle/>
           <a:p>
-            <a:pPr indent="0" marL="0">
+            <a:pPr marL="0" indent="0">
               <a:buNone/>
             </a:pPr>
             <a:r>
@@ -3810,15 +6493,15 @@
       </p:sp>
       <p:pic>
         <p:nvPicPr>
-          <p:cNvPr id="22" name="Image 3" descr="preencoded.png">    </p:cNvPr>
+          <p:cNvPr id="22" name="Image 3" descr="preencoded.png"/>
           <p:cNvPicPr>
             <a:picLocks noChangeAspect="1"/>
           </p:cNvPicPr>
           <p:nvPr/>
         </p:nvPicPr>
         <p:blipFill>
-          <a:blip r:embed="rId4"/>
-          <a:srcRect l="0" r="0" t="0" b="0"/>
+          <a:blip r:embed="rId6"/>
+          <a:srcRect/>
           <a:stretch/>
         </p:blipFill>
         <p:spPr>
@@ -3874,11 +6557,11 @@
           <a:bodyPr wrap="square" lIns="0" tIns="0" rIns="0" bIns="0" rtlCol="0" anchor="ctr"/>
           <a:lstStyle/>
           <a:p>
-            <a:pPr indent="0" marL="0">
-              <a:buNone/>
-            </a:pPr>
-            <a:r>
-              <a:rPr lang="en-US" sz="950" b="1" spc="30" kern="0" dirty="0">
+            <a:pPr marL="0" indent="0">
+              <a:buNone/>
+            </a:pPr>
+            <a:r>
+              <a:rPr lang="en-US" sz="950" b="1" kern="0" spc="30" dirty="0">
                 <a:solidFill>
                   <a:srgbClr val="5C6B76"/>
                 </a:solidFill>
@@ -3913,7 +6596,7 @@
           <a:bodyPr wrap="square" lIns="0" tIns="0" rIns="0" bIns="0" rtlCol="0" anchor="ctr"/>
           <a:lstStyle/>
           <a:p>
-            <a:pPr indent="0" marL="0">
+            <a:pPr marL="0" indent="0">
               <a:buNone/>
             </a:pPr>
             <a:r>
@@ -3952,7 +6635,7 @@
           <a:bodyPr wrap="square" lIns="0" tIns="0" rIns="0" bIns="0" rtlCol="0" anchor="ctr"/>
           <a:lstStyle/>
           <a:p>
-            <a:pPr indent="0" marL="0">
+            <a:pPr marL="0" indent="0">
               <a:buNone/>
             </a:pPr>
             <a:r>
@@ -3991,7 +6674,7 @@
           <a:bodyPr wrap="square" lIns="0" tIns="0" rIns="0" bIns="0" rtlCol="0" anchor="ctr"/>
           <a:lstStyle/>
           <a:p>
-            <a:pPr indent="0" marL="0">
+            <a:pPr marL="0" indent="0">
               <a:buNone/>
             </a:pPr>
             <a:r>
@@ -4030,7 +6713,7 @@
           <a:bodyPr wrap="square" lIns="0" tIns="0" rIns="0" bIns="0" rtlCol="0" anchor="ctr"/>
           <a:lstStyle/>
           <a:p>
-            <a:pPr indent="0" marL="0">
+            <a:pPr marL="0" indent="0">
               <a:buNone/>
             </a:pPr>
             <a:r>
@@ -4091,7 +6774,7 @@
           <a:bodyPr wrap="square" lIns="0" tIns="0" rIns="0" bIns="0" rtlCol="0" anchor="ctr"/>
           <a:lstStyle/>
           <a:p>
-            <a:pPr indent="0" marL="0">
+            <a:pPr marL="0" indent="0">
               <a:buNone/>
             </a:pPr>
             <a:r>
@@ -4105,9 +6788,6 @@
               </a:rPr>
               <a:t>KEY POINT   </a:t>
             </a:r>
-            <a:pPr indent="0" marL="0">
-              <a:buNone/>
-            </a:pPr>
             <a:r>
               <a:rPr lang="en-US" sz="1100" dirty="0">
                 <a:solidFill>
@@ -4144,7 +6824,7 @@
           <a:bodyPr wrap="square" lIns="0" tIns="0" rIns="0" bIns="0" rtlCol="0" anchor="ctr"/>
           <a:lstStyle/>
           <a:p>
-            <a:pPr indent="0" marL="0">
+            <a:pPr marL="0" indent="0">
               <a:buNone/>
             </a:pPr>
             <a:r>
@@ -4463,4 +7143,319 @@
     </a:ext>
   </a:extLst>
 </a:theme>
+</file>
+
+<file path=ppt/theme/theme2.xml><?xml version="1.0" encoding="utf-8"?>
+<a:theme xmlns:a="http://schemas.openxmlformats.org/drawingml/2006/main" name="Office Theme">
+  <a:themeElements>
+    <a:clrScheme name="Office">
+      <a:dk1>
+        <a:sysClr val="windowText" lastClr="000000"/>
+      </a:dk1>
+      <a:lt1>
+        <a:sysClr val="window" lastClr="FFFFFF"/>
+      </a:lt1>
+      <a:dk2>
+        <a:srgbClr val="0E2841"/>
+      </a:dk2>
+      <a:lt2>
+        <a:srgbClr val="E8E8E8"/>
+      </a:lt2>
+      <a:accent1>
+        <a:srgbClr val="156082"/>
+      </a:accent1>
+      <a:accent2>
+        <a:srgbClr val="E97132"/>
+      </a:accent2>
+      <a:accent3>
+        <a:srgbClr val="196B24"/>
+      </a:accent3>
+      <a:accent4>
+        <a:srgbClr val="0F9ED5"/>
+      </a:accent4>
+      <a:accent5>
+        <a:srgbClr val="A02B93"/>
+      </a:accent5>
+      <a:accent6>
+        <a:srgbClr val="4EA72E"/>
+      </a:accent6>
+      <a:hlink>
+        <a:srgbClr val="467886"/>
+      </a:hlink>
+      <a:folHlink>
+        <a:srgbClr val="96607D"/>
+      </a:folHlink>
+    </a:clrScheme>
+    <a:fontScheme name="Office">
+      <a:majorFont>
+        <a:latin typeface="Aptos Display" panose="02110004020202020204"/>
+        <a:ea typeface=""/>
+        <a:cs typeface=""/>
+        <a:font script="Jpan" typeface="游ゴシック Light"/>
+        <a:font script="Hang" typeface="맑은 고딕"/>
+        <a:font script="Hans" typeface="等线 Light"/>
+        <a:font script="Hant" typeface="新細明體"/>
+        <a:font script="Arab" typeface="Times New Roman"/>
+        <a:font script="Hebr" typeface="Times New Roman"/>
+        <a:font script="Thai" typeface="Angsana New"/>
+        <a:font script="Ethi" typeface="Nyala"/>
+        <a:font script="Beng" typeface="Vrinda"/>
+        <a:font script="Gujr" typeface="Shruti"/>
+        <a:font script="Khmr" typeface="MoolBoran"/>
+        <a:font script="Knda" typeface="Tunga"/>
+        <a:font script="Guru" typeface="Raavi"/>
+        <a:font script="Cans" typeface="Euphemia"/>
+        <a:font script="Cher" typeface="Plantagenet Cherokee"/>
+        <a:font script="Yiii" typeface="Microsoft Yi Baiti"/>
+        <a:font script="Tibt" typeface="Microsoft Himalaya"/>
+        <a:font script="Thaa" typeface="MV Boli"/>
+        <a:font script="Deva" typeface="Mangal"/>
+        <a:font script="Telu" typeface="Gautami"/>
+        <a:font script="Taml" typeface="Latha"/>
+        <a:font script="Syrc" typeface="Estrangelo Edessa"/>
+        <a:font script="Orya" typeface="Kalinga"/>
+        <a:font script="Mlym" typeface="Kartika"/>
+        <a:font script="Laoo" typeface="DokChampa"/>
+        <a:font script="Sinh" typeface="Iskoola Pota"/>
+        <a:font script="Mong" typeface="Mongolian Baiti"/>
+        <a:font script="Viet" typeface="Times New Roman"/>
+        <a:font script="Uigh" typeface="Microsoft Uighur"/>
+        <a:font script="Geor" typeface="Sylfaen"/>
+        <a:font script="Armn" typeface="Arial"/>
+        <a:font script="Bugi" typeface="Leelawadee UI"/>
+        <a:font script="Bopo" typeface="Microsoft JhengHei"/>
+        <a:font script="Java" typeface="Javanese Text"/>
+        <a:font script="Lisu" typeface="Segoe UI"/>
+        <a:font script="Mymr" typeface="Myanmar Text"/>
+        <a:font script="Nkoo" typeface="Ebrima"/>
+        <a:font script="Olck" typeface="Nirmala UI"/>
+        <a:font script="Osma" typeface="Ebrima"/>
+        <a:font script="Phag" typeface="Phagspa"/>
+        <a:font script="Syrn" typeface="Estrangelo Edessa"/>
+        <a:font script="Syrj" typeface="Estrangelo Edessa"/>
+        <a:font script="Syre" typeface="Estrangelo Edessa"/>
+        <a:font script="Sora" typeface="Nirmala UI"/>
+        <a:font script="Tale" typeface="Microsoft Tai Le"/>
+        <a:font script="Talu" typeface="Microsoft New Tai Lue"/>
+        <a:font script="Tfng" typeface="Ebrima"/>
+      </a:majorFont>
+      <a:minorFont>
+        <a:latin typeface="Aptos" panose="02110004020202020204"/>
+        <a:ea typeface=""/>
+        <a:cs typeface=""/>
+        <a:font script="Jpan" typeface="游ゴシック"/>
+        <a:font script="Hang" typeface="맑은 고딕"/>
+        <a:font script="Hans" typeface="等线"/>
+        <a:font script="Hant" typeface="新細明體"/>
+        <a:font script="Arab" typeface="Arial"/>
+        <a:font script="Hebr" typeface="Arial"/>
+        <a:font script="Thai" typeface="Cordia New"/>
+        <a:font script="Ethi" typeface="Nyala"/>
+        <a:font script="Beng" typeface="Vrinda"/>
+        <a:font script="Gujr" typeface="Shruti"/>
+        <a:font script="Khmr" typeface="DaunPenh"/>
+        <a:font script="Knda" typeface="Tunga"/>
+        <a:font script="Guru" typeface="Raavi"/>
+        <a:font script="Cans" typeface="Euphemia"/>
+        <a:font script="Cher" typeface="Plantagenet Cherokee"/>
+        <a:font script="Yiii" typeface="Microsoft Yi Baiti"/>
+        <a:font script="Tibt" typeface="Microsoft Himalaya"/>
+        <a:font script="Thaa" typeface="MV Boli"/>
+        <a:font script="Deva" typeface="Mangal"/>
+        <a:font script="Telu" typeface="Gautami"/>
+        <a:font script="Taml" typeface="Latha"/>
+        <a:font script="Syrc" typeface="Estrangelo Edessa"/>
+        <a:font script="Orya" typeface="Kalinga"/>
+        <a:font script="Mlym" typeface="Kartika"/>
+        <a:font script="Laoo" typeface="DokChampa"/>
+        <a:font script="Sinh" typeface="Iskoola Pota"/>
+        <a:font script="Mong" typeface="Mongolian Baiti"/>
+        <a:font script="Viet" typeface="Arial"/>
+        <a:font script="Uigh" typeface="Microsoft Uighur"/>
+        <a:font script="Geor" typeface="Sylfaen"/>
+        <a:font script="Armn" typeface="Arial"/>
+        <a:font script="Bugi" typeface="Leelawadee UI"/>
+        <a:font script="Bopo" typeface="Microsoft JhengHei"/>
+        <a:font script="Java" typeface="Javanese Text"/>
+        <a:font script="Lisu" typeface="Segoe UI"/>
+        <a:font script="Mymr" typeface="Myanmar Text"/>
+        <a:font script="Nkoo" typeface="Ebrima"/>
+        <a:font script="Olck" typeface="Nirmala UI"/>
+        <a:font script="Osma" typeface="Ebrima"/>
+        <a:font script="Phag" typeface="Phagspa"/>
+        <a:font script="Syrn" typeface="Estrangelo Edessa"/>
+        <a:font script="Syrj" typeface="Estrangelo Edessa"/>
+        <a:font script="Syre" typeface="Estrangelo Edessa"/>
+        <a:font script="Sora" typeface="Nirmala UI"/>
+        <a:font script="Tale" typeface="Microsoft Tai Le"/>
+        <a:font script="Talu" typeface="Microsoft New Tai Lue"/>
+        <a:font script="Tfng" typeface="Ebrima"/>
+      </a:minorFont>
+    </a:fontScheme>
+    <a:fmtScheme name="Office">
+      <a:fillStyleLst>
+        <a:solidFill>
+          <a:schemeClr val="phClr"/>
+        </a:solidFill>
+        <a:gradFill rotWithShape="1">
+          <a:gsLst>
+            <a:gs pos="0">
+              <a:schemeClr val="phClr">
+                <a:lumMod val="110000"/>
+                <a:satMod val="105000"/>
+                <a:tint val="67000"/>
+              </a:schemeClr>
+            </a:gs>
+            <a:gs pos="50000">
+              <a:schemeClr val="phClr">
+                <a:lumMod val="105000"/>
+                <a:satMod val="103000"/>
+                <a:tint val="73000"/>
+              </a:schemeClr>
+            </a:gs>
+            <a:gs pos="100000">
+              <a:schemeClr val="phClr">
+                <a:lumMod val="105000"/>
+                <a:satMod val="109000"/>
+                <a:tint val="81000"/>
+              </a:schemeClr>
+            </a:gs>
+          </a:gsLst>
+          <a:lin ang="5400000" scaled="0"/>
+        </a:gradFill>
+        <a:gradFill rotWithShape="1">
+          <a:gsLst>
+            <a:gs pos="0">
+              <a:schemeClr val="phClr">
+                <a:satMod val="103000"/>
+                <a:lumMod val="102000"/>
+                <a:tint val="94000"/>
+              </a:schemeClr>
+            </a:gs>
+            <a:gs pos="50000">
+              <a:schemeClr val="phClr">
+                <a:satMod val="110000"/>
+                <a:lumMod val="100000"/>
+                <a:shade val="100000"/>
+              </a:schemeClr>
+            </a:gs>
+            <a:gs pos="100000">
+              <a:schemeClr val="phClr">
+                <a:lumMod val="99000"/>
+                <a:satMod val="120000"/>
+                <a:shade val="78000"/>
+              </a:schemeClr>
+            </a:gs>
+          </a:gsLst>
+          <a:lin ang="5400000" scaled="0"/>
+        </a:gradFill>
+      </a:fillStyleLst>
+      <a:lnStyleLst>
+        <a:ln w="12700" cap="flat" cmpd="sng" algn="ctr">
+          <a:solidFill>
+            <a:schemeClr val="phClr"/>
+          </a:solidFill>
+          <a:prstDash val="solid"/>
+          <a:miter lim="800000"/>
+        </a:ln>
+        <a:ln w="19050" cap="flat" cmpd="sng" algn="ctr">
+          <a:solidFill>
+            <a:schemeClr val="phClr"/>
+          </a:solidFill>
+          <a:prstDash val="solid"/>
+          <a:miter lim="800000"/>
+        </a:ln>
+        <a:ln w="25400" cap="flat" cmpd="sng" algn="ctr">
+          <a:solidFill>
+            <a:schemeClr val="phClr"/>
+          </a:solidFill>
+          <a:prstDash val="solid"/>
+          <a:miter lim="800000"/>
+        </a:ln>
+      </a:lnStyleLst>
+      <a:effectStyleLst>
+        <a:effectStyle>
+          <a:effectLst/>
+        </a:effectStyle>
+        <a:effectStyle>
+          <a:effectLst/>
+        </a:effectStyle>
+        <a:effectStyle>
+          <a:effectLst>
+            <a:outerShdw blurRad="57150" dist="19050" dir="5400000" algn="ctr" rotWithShape="0">
+              <a:srgbClr val="000000">
+                <a:alpha val="63000"/>
+              </a:srgbClr>
+            </a:outerShdw>
+          </a:effectLst>
+        </a:effectStyle>
+      </a:effectStyleLst>
+      <a:bgFillStyleLst>
+        <a:solidFill>
+          <a:schemeClr val="phClr"/>
+        </a:solidFill>
+        <a:solidFill>
+          <a:schemeClr val="phClr">
+            <a:tint val="95000"/>
+            <a:satMod val="170000"/>
+          </a:schemeClr>
+        </a:solidFill>
+        <a:gradFill rotWithShape="1">
+          <a:gsLst>
+            <a:gs pos="0">
+              <a:schemeClr val="phClr">
+                <a:tint val="93000"/>
+                <a:satMod val="150000"/>
+                <a:shade val="98000"/>
+                <a:lumMod val="102000"/>
+              </a:schemeClr>
+            </a:gs>
+            <a:gs pos="50000">
+              <a:schemeClr val="phClr">
+                <a:tint val="98000"/>
+                <a:satMod val="130000"/>
+                <a:shade val="90000"/>
+                <a:lumMod val="103000"/>
+              </a:schemeClr>
+            </a:gs>
+            <a:gs pos="100000">
+              <a:schemeClr val="phClr">
+                <a:shade val="63000"/>
+                <a:satMod val="120000"/>
+              </a:schemeClr>
+            </a:gs>
+          </a:gsLst>
+          <a:lin ang="5400000" scaled="0"/>
+        </a:gradFill>
+      </a:bgFillStyleLst>
+    </a:fmtScheme>
+  </a:themeElements>
+  <a:objectDefaults>
+    <a:lnDef>
+      <a:spPr/>
+      <a:bodyPr/>
+      <a:lstStyle/>
+      <a:style>
+        <a:lnRef idx="2">
+          <a:schemeClr val="accent1"/>
+        </a:lnRef>
+        <a:fillRef idx="0">
+          <a:schemeClr val="accent1"/>
+        </a:fillRef>
+        <a:effectRef idx="1">
+          <a:schemeClr val="accent1"/>
+        </a:effectRef>
+        <a:fontRef idx="minor">
+          <a:schemeClr val="tx1"/>
+        </a:fontRef>
+      </a:style>
+    </a:lnDef>
+  </a:objectDefaults>
+  <a:extraClrSchemeLst/>
+  <a:extLst>
+    <a:ext uri="{05A4C25C-085E-4340-85A3-A5531E510DB2}">
+      <thm15:themeFamily xmlns:thm15="http://schemas.microsoft.com/office/thememl/2012/main" name="Office Theme" id="{2E142A2C-CD16-42D6-873A-C26D2A0506FA}" vid="{1BDDFF52-6CD6-40A5-AB3C-68EB2F1E4D0A}"/>
+    </a:ext>
+  </a:extLst>
+</a:theme>
 </file>
</xml_diff>